<commit_message>
fix(audio): align verbatim statement text with master audio & enable strict matching with dynamic 6-language Sarvam TTS
</commit_message>
<xml_diff>
--- a/Saransh_BPUT_Keynote_Pitch.pptx
+++ b/Saransh_BPUT_Keynote_Pitch.pptx
@@ -13,6 +13,7 @@
     <p:sldId id="261" r:id="rId12"/>
     <p:sldId id="262" r:id="rId13"/>
     <p:sldId id="263" r:id="rId14"/>
+    <p:sldId id="264" r:id="rId15"/>
   </p:sldIdLst>
   <p:sldSz cx="12191695" cy="6858000" type="screen4x3"/>
   <p:notesSz cx="6858000" cy="9144000"/>
@@ -4535,7 +4536,7 @@
               </a:defRPr>
             </a:pPr>
             <a:r>
-              <a:t>Our Solution: Hybrid Deterministic + Generative Triage Engine</a:t>
+              <a:t>System Ideation: From Waiting Room Chaos to Prioritized Triage Lanes</a:t>
             </a:r>
           </a:p>
         </p:txBody>
@@ -4592,7 +4593,7 @@
         <p:spPr>
           <a:xfrm>
             <a:off x="731520" y="1508760"/>
-            <a:ext cx="5212080" cy="4892040"/>
+            <a:ext cx="5486400" cy="3154680"/>
           </a:xfrm>
           <a:prstGeom prst="roundRect">
             <a:avLst/>
@@ -4621,122 +4622,47 @@
           </a:fontRef>
         </p:style>
         <p:txBody>
-          <a:bodyPr rtlCol="0" anchor="ctr" wrap="square"/>
-          <a:lstStyle/>
-          <a:p>
-            <a:pPr algn="ctr">
-              <a:defRPr sz="1600" b="1">
-                <a:solidFill>
-                  <a:srgbClr val="FFFFFF"/>
-                </a:solidFill>
-              </a:defRPr>
-            </a:pPr>
-            <a:r>
-              <a:t>Why NOT a Generic Black-Box LLM?</a:t>
-            </a:r>
-          </a:p>
-          <a:p>
-            <a:pPr>
-              <a:spcBef>
-                <a:spcPts val="600"/>
-              </a:spcBef>
-              <a:defRPr sz="1000">
-                <a:solidFill>
-                  <a:srgbClr val="F1F5F9"/>
-                </a:solidFill>
-              </a:defRPr>
-            </a:pPr>
-            <a:r>
-              <a:t>❌ Pure LLM Pitfall: Autonomous LLMs can hallucinate, downgrade critical vitals, or generate unauthorized medical prescriptions.</a:t>
-            </a:r>
-          </a:p>
-          <a:p>
-            <a:pPr>
-              <a:spcBef>
-                <a:spcPts val="600"/>
-              </a:spcBef>
-              <a:defRPr sz="1000">
-                <a:solidFill>
-                  <a:srgbClr val="F1F5F9"/>
-                </a:solidFill>
-              </a:defRPr>
-            </a:pPr>
-            <a:r>
-              <a:t>🛡️ The Saransh Hybrid Innovation: We separate Clinical Safety from Linguistic Processing:</a:t>
-            </a:r>
-          </a:p>
-          <a:p>
-            <a:pPr>
-              <a:spcBef>
-                <a:spcPts val="600"/>
-              </a:spcBef>
-              <a:defRPr sz="1000">
-                <a:solidFill>
-                  <a:srgbClr val="F1F5F9"/>
-                </a:solidFill>
-              </a:defRPr>
-            </a:pPr>
-            <a:r>
-              <a:t>1. Deterministic Rule Engine (100% Explainable): Hard clinical vital checks in pure Python/JS. SpO2 &lt; 90% = RED. Systolic BP &gt;= 180 = RED. Severe Chest Pain = RED. Zero AI hallucination on vitals.</a:t>
-            </a:r>
-          </a:p>
-          <a:p>
-            <a:pPr>
-              <a:spcBef>
-                <a:spcPts val="600"/>
-              </a:spcBef>
-              <a:defRPr sz="1000">
-                <a:solidFill>
-                  <a:srgbClr val="F1F5F9"/>
-                </a:solidFill>
-              </a:defRPr>
-            </a:pPr>
-            <a:r>
-              <a:t>2. Generative Multimodal AI (Gemini 2.5 Flash): Used strictly for multimodal transcription, CBC/ECG OCR extraction, chronological timeline stepper, and Odia/Hindi follow-up question generation.</a:t>
-            </a:r>
-          </a:p>
-          <a:p>
-            <a:pPr>
-              <a:spcBef>
-                <a:spcPts val="600"/>
-              </a:spcBef>
-              <a:defRPr sz="1000">
-                <a:solidFill>
-                  <a:srgbClr val="F1F5F9"/>
-                </a:solidFill>
-              </a:defRPr>
-            </a:pPr>
-            <a:r>
-              <a:t>3. MAX(Rule, AI) Safety Floor Ceiling: Programmatic guarantee: The AI model cannot downgrade a patient flagged as an emergency by clinical rules.</a:t>
-            </a:r>
-          </a:p>
-          <a:p>
-            <a:pPr>
-              <a:spcBef>
-                <a:spcPts val="600"/>
-              </a:spcBef>
-              <a:defRPr sz="1000">
-                <a:solidFill>
-                  <a:srgbClr val="F1F5F9"/>
-                </a:solidFill>
-              </a:defRPr>
-            </a:pPr>
-            <a:r>
-              <a:t>4. Strict Advisory Mandate: Persistent disclaimer: Clinical decision support tool for qualified staff; does not diagnose or prescribe.</a:t>
-            </a:r>
-          </a:p>
-        </p:txBody>
-      </p:sp>
-      <p:sp>
-        <p:nvSpPr>
-          <p:cNvPr id="8" name="Rounded Rectangle 7"/>
+          <a:bodyPr rtlCol="0" anchor="ctr"/>
+          <a:lstStyle/>
+          <a:p>
+            <a:pPr algn="ctr"/>
+          </a:p>
+        </p:txBody>
+      </p:sp>
+      <p:pic>
+        <p:nvPicPr>
+          <p:cNvPr id="8" name="Picture 7" descr="saransh_ideation.jpg"/>
+          <p:cNvPicPr>
+            <a:picLocks noChangeAspect="1"/>
+          </p:cNvPicPr>
+          <p:nvPr/>
+        </p:nvPicPr>
+        <p:blipFill>
+          <a:blip r:embed="rId2"/>
+          <a:stretch>
+            <a:fillRect/>
+          </a:stretch>
+        </p:blipFill>
+        <p:spPr>
+          <a:xfrm>
+            <a:off x="777240" y="1554480"/>
+            <a:ext cx="5394960" cy="3063240"/>
+          </a:xfrm>
+          <a:prstGeom prst="rect">
+            <a:avLst/>
+          </a:prstGeom>
+        </p:spPr>
+      </p:pic>
+      <p:sp>
+        <p:nvSpPr>
+          <p:cNvPr id="9" name="Rounded Rectangle 8"/>
           <p:cNvSpPr/>
           <p:nvPr/>
         </p:nvSpPr>
         <p:spPr>
           <a:xfrm>
-            <a:off x="6172200" y="1508760"/>
-            <a:ext cx="5285232" cy="1508760"/>
+            <a:off x="731520" y="4800600"/>
+            <a:ext cx="5486400" cy="1600200"/>
           </a:xfrm>
           <a:prstGeom prst="roundRect">
             <a:avLst/>
@@ -4744,9 +4670,9 @@
           <a:solidFill>
             <a:srgbClr val="131A2A"/>
           </a:solidFill>
-          <a:ln w="19050">
+          <a:ln w="12700">
             <a:solidFill>
-              <a:srgbClr val="F43F5E"/>
+              <a:srgbClr val="27324B"/>
             </a:solidFill>
           </a:ln>
         </p:spPr>
@@ -4771,56 +4697,41 @@
             <a:pPr algn="ctr">
               <a:defRPr sz="1300" b="1">
                 <a:solidFill>
-                  <a:srgbClr val="F43F5E"/>
-                </a:solidFill>
-              </a:defRPr>
-            </a:pPr>
-            <a:r>
-              <a:t>🔴 RED — EMERGENCY (P1)</a:t>
+                  <a:srgbClr val="38BDF8"/>
+                </a:solidFill>
+              </a:defRPr>
+            </a:pPr>
+            <a:r>
+              <a:t>💡 The Ideation Genesis &amp; Core Hypothesis</a:t>
             </a:r>
           </a:p>
           <a:p>
             <a:pPr>
               <a:spcBef>
-                <a:spcPts val="200"/>
+                <a:spcPts val="400"/>
               </a:spcBef>
-              <a:defRPr sz="1000" b="1">
-                <a:solidFill>
-                  <a:srgbClr val="FFFFFF"/>
-                </a:solidFill>
-              </a:defRPr>
-            </a:pPr>
-            <a:r>
-              <a:t>Queue SLA: Immediate Medical Officer Care (0 min wait)</a:t>
-            </a:r>
-          </a:p>
-          <a:p>
-            <a:pPr>
-              <a:spcBef>
-                <a:spcPts val="300"/>
-              </a:spcBef>
-              <a:defRPr sz="950">
-                <a:solidFill>
-                  <a:srgbClr val="94A3B8"/>
-                </a:solidFill>
-              </a:defRPr>
-            </a:pPr>
-            <a:r>
-              <a:t>Clinical Triggers: SpO2 &lt; 90% • Systolic BP &gt;= 180 or &lt; 85 • Severe Retrosternal Chest Pain • Acute Dyspnea • Active Seizure • Anaphylaxis</a:t>
-            </a:r>
-          </a:p>
-        </p:txBody>
-      </p:sp>
-      <p:sp>
-        <p:nvSpPr>
-          <p:cNvPr id="9" name="Rounded Rectangle 8"/>
+              <a:defRPr sz="1000" i="1">
+                <a:solidFill>
+                  <a:srgbClr val="F1F5F9"/>
+                </a:solidFill>
+              </a:defRPr>
+            </a:pPr>
+            <a:r>
+              <a:t>“Can we convert subjective colloquial distress ('Chhati pathara bhali bhari') into objective, life-saving clinical urgency lanes in &lt;30 seconds—while guaranteeing zero AI hallucination on vital signs?”</a:t>
+            </a:r>
+          </a:p>
+        </p:txBody>
+      </p:sp>
+      <p:sp>
+        <p:nvSpPr>
+          <p:cNvPr id="10" name="Rounded Rectangle 9"/>
           <p:cNvSpPr/>
           <p:nvPr/>
         </p:nvSpPr>
         <p:spPr>
           <a:xfrm>
-            <a:off x="6172200" y="3136391"/>
-            <a:ext cx="5285232" cy="1508760"/>
+            <a:off x="6492240" y="1508760"/>
+            <a:ext cx="4967935" cy="4892040"/>
           </a:xfrm>
           <a:prstGeom prst="roundRect">
             <a:avLst/>
@@ -4830,7 +4741,7 @@
           </a:solidFill>
           <a:ln w="19050">
             <a:solidFill>
-              <a:srgbClr val="F59E0B"/>
+              <a:srgbClr val="27324B"/>
             </a:solidFill>
           </a:ln>
         </p:spPr>
@@ -4853,128 +4764,134 @@
           <a:lstStyle/>
           <a:p>
             <a:pPr algn="ctr">
-              <a:defRPr sz="1300" b="1">
-                <a:solidFill>
-                  <a:srgbClr val="F59E0B"/>
-                </a:solidFill>
-              </a:defRPr>
-            </a:pPr>
-            <a:r>
-              <a:t>🟠 YELLOW — URGENT (P2)</a:t>
+              <a:defRPr sz="1500" b="1">
+                <a:solidFill>
+                  <a:srgbClr val="FFFFFF"/>
+                </a:solidFill>
+              </a:defRPr>
+            </a:pPr>
+            <a:r>
+              <a:t>⚙️ Design Thinking &amp; Technology Convergence</a:t>
             </a:r>
           </a:p>
           <a:p>
             <a:pPr>
               <a:spcBef>
-                <a:spcPts val="200"/>
+                <a:spcPts val="600"/>
               </a:spcBef>
-              <a:defRPr sz="1000" b="1">
-                <a:solidFill>
-                  <a:srgbClr val="FFFFFF"/>
-                </a:solidFill>
-              </a:defRPr>
-            </a:pPr>
-            <a:r>
-              <a:t>Queue SLA: Priority Fast-Track OPD (&lt; 15-20 min target)</a:t>
+              <a:defRPr sz="1050" b="1">
+                <a:solidFill>
+                  <a:srgbClr val="14B8A6"/>
+                </a:solidFill>
+              </a:defRPr>
+            </a:pPr>
+            <a:r>
+              <a:t>• 1. User-Centric Empathy (The ASHA/ANM Reality):</a:t>
             </a:r>
           </a:p>
           <a:p>
             <a:pPr>
               <a:spcBef>
-                <a:spcPts val="300"/>
+                <a:spcPts val="100"/>
               </a:spcBef>
               <a:defRPr sz="950">
                 <a:solidFill>
-                  <a:srgbClr val="94A3B8"/>
-                </a:solidFill>
-              </a:defRPr>
-            </a:pPr>
-            <a:r>
-              <a:t>Clinical Triggers: SpO2 90-93% • Temp &gt;= 101.5°F • Abnormal CBC (Platelets &lt; 100k) • High-Risk Maternal Pre-eclampsia (BP 168/110)</a:t>
-            </a:r>
-          </a:p>
-        </p:txBody>
-      </p:sp>
-      <p:sp>
-        <p:nvSpPr>
-          <p:cNvPr id="10" name="Rounded Rectangle 9"/>
-          <p:cNvSpPr/>
-          <p:nvPr/>
-        </p:nvSpPr>
-        <p:spPr>
-          <a:xfrm>
-            <a:off x="6172200" y="4764024"/>
-            <a:ext cx="5285232" cy="1508760"/>
-          </a:xfrm>
-          <a:prstGeom prst="roundRect">
-            <a:avLst/>
-          </a:prstGeom>
-          <a:solidFill>
-            <a:srgbClr val="131A2A"/>
-          </a:solidFill>
-          <a:ln w="19050">
-            <a:solidFill>
-              <a:srgbClr val="10B981"/>
-            </a:solidFill>
-          </a:ln>
-        </p:spPr>
-        <p:style>
-          <a:lnRef idx="1">
-            <a:schemeClr val="accent1"/>
-          </a:lnRef>
-          <a:fillRef idx="3">
-            <a:schemeClr val="accent1"/>
-          </a:fillRef>
-          <a:effectRef idx="2">
-            <a:schemeClr val="accent1"/>
-          </a:effectRef>
-          <a:fontRef idx="minor">
-            <a:schemeClr val="lt1"/>
-          </a:fontRef>
-        </p:style>
-        <p:txBody>
-          <a:bodyPr rtlCol="0" anchor="ctr" wrap="square"/>
-          <a:lstStyle/>
-          <a:p>
-            <a:pPr algn="ctr">
-              <a:defRPr sz="1300" b="1">
-                <a:solidFill>
-                  <a:srgbClr val="10B981"/>
-                </a:solidFill>
-              </a:defRPr>
-            </a:pPr>
-            <a:r>
-              <a:t>🟢 GREEN — ROUTINE (P3)</a:t>
+                  <a:srgbClr val="F1F5F9"/>
+                </a:solidFill>
+              </a:defRPr>
+            </a:pPr>
+            <a:r>
+              <a:t>Frontline staff have under 90s per patient. We designed an interactive 2D Anatomical Body Map so non-literate patients can visually tap pain points with zero typing.</a:t>
             </a:r>
           </a:p>
           <a:p>
             <a:pPr>
               <a:spcBef>
-                <a:spcPts val="200"/>
+                <a:spcPts val="600"/>
               </a:spcBef>
-              <a:defRPr sz="1000" b="1">
-                <a:solidFill>
-                  <a:srgbClr val="FFFFFF"/>
-                </a:solidFill>
-              </a:defRPr>
-            </a:pPr>
-            <a:r>
-              <a:t>Queue SLA: Standard Outpatient Queue Consultation</a:t>
+              <a:defRPr sz="1050" b="1">
+                <a:solidFill>
+                  <a:srgbClr val="14B8A6"/>
+                </a:solidFill>
+              </a:defRPr>
+            </a:pPr>
+            <a:r>
+              <a:t>• 2. Sovereign Indic Vernacular AI (Sarvam AI):</a:t>
             </a:r>
           </a:p>
           <a:p>
             <a:pPr>
               <a:spcBef>
-                <a:spcPts val="300"/>
+                <a:spcPts val="100"/>
               </a:spcBef>
               <a:defRPr sz="950">
                 <a:solidFill>
-                  <a:srgbClr val="94A3B8"/>
-                </a:solidFill>
-              </a:defRPr>
-            </a:pPr>
-            <a:r>
-              <a:t>Clinical Triggers: SpO2 &gt;= 94% • Baseline Stable Vitals • Mild Tension Headache • Chronic Medication Refill • Minor Cold/Cough</a:t>
+                  <a:srgbClr val="F1F5F9"/>
+                </a:solidFill>
+              </a:defRPr>
+            </a:pPr>
+            <a:r>
+              <a:t>Integrating India's Saaras:v3 &amp; Bulbul:v3 to recognize spoken Odia &amp; Hindi cultural idioms, outputting phonetic transcripts &amp; standardized medical English.</a:t>
+            </a:r>
+          </a:p>
+          <a:p>
+            <a:pPr>
+              <a:spcBef>
+                <a:spcPts val="600"/>
+              </a:spcBef>
+              <a:defRPr sz="1050" b="1">
+                <a:solidFill>
+                  <a:srgbClr val="14B8A6"/>
+                </a:solidFill>
+              </a:defRPr>
+            </a:pPr>
+            <a:r>
+              <a:t>• 3. The Mathematical Safety Guardrail (AIIMS/WHO):</a:t>
+            </a:r>
+          </a:p>
+          <a:p>
+            <a:pPr>
+              <a:spcBef>
+                <a:spcPts val="100"/>
+              </a:spcBef>
+              <a:defRPr sz="950">
+                <a:solidFill>
+                  <a:srgbClr val="F1F5F9"/>
+                </a:solidFill>
+              </a:defRPr>
+            </a:pPr>
+            <a:r>
+              <a:t>Refusing black-box LLM risk: vital thresholds enforce an unbreakable floor via MAX(Rule, AI). If SpO2 &lt; 90%, it locks RED regardless of AI output.</a:t>
+            </a:r>
+          </a:p>
+          <a:p>
+            <a:pPr>
+              <a:spcBef>
+                <a:spcPts val="600"/>
+              </a:spcBef>
+              <a:defRPr sz="1050" b="1">
+                <a:solidFill>
+                  <a:srgbClr val="14B8A6"/>
+                </a:solidFill>
+              </a:defRPr>
+            </a:pPr>
+            <a:r>
+              <a:t>• 4. National Health Continuity (ABDM FHIR R4):</a:t>
+            </a:r>
+          </a:p>
+          <a:p>
+            <a:pPr>
+              <a:spcBef>
+                <a:spcPts val="100"/>
+              </a:spcBef>
+              <a:defRPr sz="950">
+                <a:solidFill>
+                  <a:srgbClr val="F1F5F9"/>
+                </a:solidFill>
+              </a:defRPr>
+            </a:pPr>
+            <a:r>
+              <a:t>Transitioning from lost paper scraps to tamper-evident referral slips with SHA-256 cryptographic hashes for seamless PHC-to-MCH ambulance handoffs.</a:t>
             </a:r>
           </a:p>
         </p:txBody>
@@ -5169,7 +5086,7 @@
               </a:defRPr>
             </a:pPr>
             <a:r>
-              <a:t>Multimodal Ingestion: Voice, Vision, Vitals &amp; Vernacular Dialects</a:t>
+              <a:t>Our Solution: Hybrid Deterministic + Generative Triage Engine</a:t>
             </a:r>
           </a:p>
         </p:txBody>
@@ -5226,7 +5143,7 @@
         <p:spPr>
           <a:xfrm>
             <a:off x="731520" y="1508760"/>
-            <a:ext cx="2560320" cy="4892040"/>
+            <a:ext cx="5212080" cy="4892040"/>
           </a:xfrm>
           <a:prstGeom prst="roundRect">
             <a:avLst/>
@@ -5234,9 +5151,9 @@
           <a:solidFill>
             <a:srgbClr val="131A2A"/>
           </a:solidFill>
-          <a:ln w="12700">
+          <a:ln w="19050">
             <a:solidFill>
-              <a:srgbClr val="27324B"/>
+              <a:srgbClr val="14B8A6"/>
             </a:solidFill>
           </a:ln>
         </p:spPr>
@@ -5259,72 +5176,129 @@
           <a:lstStyle/>
           <a:p>
             <a:pPr algn="ctr">
-              <a:defRPr sz="1200" b="1">
+              <a:defRPr sz="1600" b="1">
                 <a:solidFill>
                   <a:srgbClr val="FFFFFF"/>
                 </a:solidFill>
               </a:defRPr>
             </a:pPr>
             <a:r>
-              <a:t>🗣️ Vernacular Dialect Normalizer</a:t>
+              <a:t>Why NOT a Generic Black-Box LLM?</a:t>
             </a:r>
           </a:p>
           <a:p>
             <a:pPr>
               <a:spcBef>
-                <a:spcPts val="800"/>
+                <a:spcPts val="600"/>
               </a:spcBef>
-              <a:defRPr sz="950">
+              <a:defRPr sz="1000">
                 <a:solidFill>
                   <a:srgbClr val="F1F5F9"/>
                 </a:solidFill>
               </a:defRPr>
             </a:pPr>
             <a:r>
-              <a:t>• Solves Indian cultural idiom gap by mapping to SNOMED-CT &amp; ICD-10:</a:t>
-            </a:r>
-            <a:br/>
-            <a:r>
-              <a:t>  - 'ଛାତି ଫାଟିଯିବା' ➔ Severe Stabbing Chest Pain [ALERT]</a:t>
-            </a:r>
-            <a:br/>
-            <a:r>
-              <a:t>  - 'ପଥର ଭଳି ଭାରି' ➔ Crushing Chest Heaviness [ALERT]</a:t>
-            </a:r>
-            <a:br/>
-            <a:r>
-              <a:t>  - 'ଝାଳରେ ଥଣ୍ଡା' ➔ Cold Diaphoresis / Shock Sign [ALERT]</a:t>
-            </a:r>
-            <a:br/>
-            <a:r>
-              <a:t>  - '୨ ଘଣ୍ଟା ହେଲା' ➔ Acute Onset (2 hours ago)</a:t>
-            </a:r>
-            <a:br/>
-            <a:r>
-              <a:t>• Preserves exact spoken voice for legal records while outputting clinical English for doctors.</a:t>
-            </a:r>
-          </a:p>
-        </p:txBody>
-      </p:sp>
-      <p:sp>
-        <p:nvSpPr>
-          <p:cNvPr id="8" name="Rectangle 7"/>
+              <a:t>❌ Pure LLM Pitfall: Autonomous LLMs can hallucinate, downgrade critical vitals, or generate unauthorized medical prescriptions.</a:t>
+            </a:r>
+          </a:p>
+          <a:p>
+            <a:pPr>
+              <a:spcBef>
+                <a:spcPts val="600"/>
+              </a:spcBef>
+              <a:defRPr sz="1000">
+                <a:solidFill>
+                  <a:srgbClr val="F1F5F9"/>
+                </a:solidFill>
+              </a:defRPr>
+            </a:pPr>
+            <a:r>
+              <a:t>🛡️ The Saransh Hybrid Innovation: We separate Clinical Safety from Linguistic Processing:</a:t>
+            </a:r>
+          </a:p>
+          <a:p>
+            <a:pPr>
+              <a:spcBef>
+                <a:spcPts val="600"/>
+              </a:spcBef>
+              <a:defRPr sz="1000">
+                <a:solidFill>
+                  <a:srgbClr val="F1F5F9"/>
+                </a:solidFill>
+              </a:defRPr>
+            </a:pPr>
+            <a:r>
+              <a:t>1. Deterministic Rule Engine (100% Explainable): Hard clinical vital checks in pure Python/JS. SpO2 &lt; 90% = RED. Systolic BP &gt;= 180 = RED. Severe Chest Pain = RED. Zero AI hallucination on vitals.</a:t>
+            </a:r>
+          </a:p>
+          <a:p>
+            <a:pPr>
+              <a:spcBef>
+                <a:spcPts val="600"/>
+              </a:spcBef>
+              <a:defRPr sz="1000">
+                <a:solidFill>
+                  <a:srgbClr val="F1F5F9"/>
+                </a:solidFill>
+              </a:defRPr>
+            </a:pPr>
+            <a:r>
+              <a:t>2. Generative Multimodal AI (Gemini 2.5 Flash): Used strictly for multimodal transcription, CBC/ECG OCR extraction, chronological timeline stepper, and Odia/Hindi follow-up question generation.</a:t>
+            </a:r>
+          </a:p>
+          <a:p>
+            <a:pPr>
+              <a:spcBef>
+                <a:spcPts val="600"/>
+              </a:spcBef>
+              <a:defRPr sz="1000">
+                <a:solidFill>
+                  <a:srgbClr val="F1F5F9"/>
+                </a:solidFill>
+              </a:defRPr>
+            </a:pPr>
+            <a:r>
+              <a:t>3. MAX(Rule, AI) Safety Floor Ceiling: Programmatic guarantee: The AI model cannot downgrade a patient flagged as an emergency by clinical rules.</a:t>
+            </a:r>
+          </a:p>
+          <a:p>
+            <a:pPr>
+              <a:spcBef>
+                <a:spcPts val="600"/>
+              </a:spcBef>
+              <a:defRPr sz="1000">
+                <a:solidFill>
+                  <a:srgbClr val="F1F5F9"/>
+                </a:solidFill>
+              </a:defRPr>
+            </a:pPr>
+            <a:r>
+              <a:t>4. Strict Advisory Mandate: Persistent disclaimer: Clinical decision support tool for qualified staff; does not diagnose or prescribe.</a:t>
+            </a:r>
+          </a:p>
+        </p:txBody>
+      </p:sp>
+      <p:sp>
+        <p:nvSpPr>
+          <p:cNvPr id="8" name="Rounded Rectangle 7"/>
           <p:cNvSpPr/>
           <p:nvPr/>
         </p:nvSpPr>
         <p:spPr>
           <a:xfrm>
-            <a:off x="731520" y="1508760"/>
-            <a:ext cx="2560320" cy="73152"/>
-          </a:xfrm>
-          <a:prstGeom prst="rect">
-            <a:avLst/>
-          </a:prstGeom>
-          <a:solidFill>
-            <a:srgbClr val="14B8A6"/>
-          </a:solidFill>
-          <a:ln>
-            <a:noFill/>
+            <a:off x="6172200" y="1508760"/>
+            <a:ext cx="5285232" cy="1508760"/>
+          </a:xfrm>
+          <a:prstGeom prst="roundRect">
+            <a:avLst/>
+          </a:prstGeom>
+          <a:solidFill>
+            <a:srgbClr val="131A2A"/>
+          </a:solidFill>
+          <a:ln w="19050">
+            <a:solidFill>
+              <a:srgbClr val="F43F5E"/>
+            </a:solidFill>
           </a:ln>
         </p:spPr>
         <p:style>
@@ -5342,10 +5316,49 @@
           </a:fontRef>
         </p:style>
         <p:txBody>
-          <a:bodyPr rtlCol="0" anchor="ctr"/>
-          <a:lstStyle/>
-          <a:p>
-            <a:pPr algn="ctr"/>
+          <a:bodyPr rtlCol="0" anchor="ctr" wrap="square"/>
+          <a:lstStyle/>
+          <a:p>
+            <a:pPr algn="ctr">
+              <a:defRPr sz="1300" b="1">
+                <a:solidFill>
+                  <a:srgbClr val="F43F5E"/>
+                </a:solidFill>
+              </a:defRPr>
+            </a:pPr>
+            <a:r>
+              <a:t>🔴 RED — EMERGENCY (P1)</a:t>
+            </a:r>
+          </a:p>
+          <a:p>
+            <a:pPr>
+              <a:spcBef>
+                <a:spcPts val="200"/>
+              </a:spcBef>
+              <a:defRPr sz="1000" b="1">
+                <a:solidFill>
+                  <a:srgbClr val="FFFFFF"/>
+                </a:solidFill>
+              </a:defRPr>
+            </a:pPr>
+            <a:r>
+              <a:t>Queue SLA: Immediate Medical Officer Care (0 min wait)</a:t>
+            </a:r>
+          </a:p>
+          <a:p>
+            <a:pPr>
+              <a:spcBef>
+                <a:spcPts val="300"/>
+              </a:spcBef>
+              <a:defRPr sz="950">
+                <a:solidFill>
+                  <a:srgbClr val="94A3B8"/>
+                </a:solidFill>
+              </a:defRPr>
+            </a:pPr>
+            <a:r>
+              <a:t>Clinical Triggers: SpO2 &lt; 90% • Systolic BP &gt;= 180 or &lt; 85 • Severe Retrosternal Chest Pain • Acute Dyspnea • Active Seizure • Anaphylaxis</a:t>
+            </a:r>
           </a:p>
         </p:txBody>
       </p:sp>
@@ -5357,8 +5370,8 @@
         </p:nvSpPr>
         <p:spPr>
           <a:xfrm>
-            <a:off x="3456432" y="1508760"/>
-            <a:ext cx="2560320" cy="4892040"/>
+            <a:off x="6172200" y="3136391"/>
+            <a:ext cx="5285232" cy="1508760"/>
           </a:xfrm>
           <a:prstGeom prst="roundRect">
             <a:avLst/>
@@ -5366,9 +5379,9 @@
           <a:solidFill>
             <a:srgbClr val="131A2A"/>
           </a:solidFill>
-          <a:ln w="12700">
+          <a:ln w="19050">
             <a:solidFill>
-              <a:srgbClr val="27324B"/>
+              <a:srgbClr val="F59E0B"/>
             </a:solidFill>
           </a:ln>
         </p:spPr>
@@ -5391,64 +5404,69 @@
           <a:lstStyle/>
           <a:p>
             <a:pPr algn="ctr">
-              <a:defRPr sz="1200" b="1">
-                <a:solidFill>
-                  <a:srgbClr val="FFFFFF"/>
-                </a:solidFill>
-              </a:defRPr>
-            </a:pPr>
-            <a:r>
-              <a:t>🪪 Holographic ABDM / ABHA Sync</a:t>
+              <a:defRPr sz="1300" b="1">
+                <a:solidFill>
+                  <a:srgbClr val="F59E0B"/>
+                </a:solidFill>
+              </a:defRPr>
+            </a:pPr>
+            <a:r>
+              <a:t>🟠 YELLOW — URGENT (P2)</a:t>
             </a:r>
           </a:p>
           <a:p>
             <a:pPr>
               <a:spcBef>
-                <a:spcPts val="800"/>
+                <a:spcPts val="200"/>
+              </a:spcBef>
+              <a:defRPr sz="1000" b="1">
+                <a:solidFill>
+                  <a:srgbClr val="FFFFFF"/>
+                </a:solidFill>
+              </a:defRPr>
+            </a:pPr>
+            <a:r>
+              <a:t>Queue SLA: Priority Fast-Track OPD (&lt; 15-20 min target)</a:t>
+            </a:r>
+          </a:p>
+          <a:p>
+            <a:pPr>
+              <a:spcBef>
+                <a:spcPts val="300"/>
               </a:spcBef>
               <a:defRPr sz="950">
                 <a:solidFill>
-                  <a:srgbClr val="F1F5F9"/>
-                </a:solidFill>
-              </a:defRPr>
-            </a:pPr>
-            <a:r>
-              <a:t>• Ayushman Bharat Digital Mission (ABDM) Integration:</a:t>
-            </a:r>
-            <a:br/>
-            <a:r>
-              <a:t>• 1-Click mock QR scan fetches verified ABHA ID (e.g. 91-4821-9923-0192)</a:t>
-            </a:r>
-            <a:br/>
-            <a:r>
-              <a:t>• Instantly pulls synced longitudinal medical history (Hypertension 5y, Type 2 Diabetes)</a:t>
-            </a:r>
-            <a:br/>
-            <a:r>
-              <a:t>• Highlights critical drug allergy alerts (Penicillin Anaphylaxis) before nurse enters symptoms.</a:t>
-            </a:r>
-          </a:p>
-        </p:txBody>
-      </p:sp>
-      <p:sp>
-        <p:nvSpPr>
-          <p:cNvPr id="10" name="Rectangle 9"/>
+                  <a:srgbClr val="94A3B8"/>
+                </a:solidFill>
+              </a:defRPr>
+            </a:pPr>
+            <a:r>
+              <a:t>Clinical Triggers: SpO2 90-93% • Temp &gt;= 101.5°F • Abnormal CBC (Platelets &lt; 100k) • High-Risk Maternal Pre-eclampsia (BP 168/110)</a:t>
+            </a:r>
+          </a:p>
+        </p:txBody>
+      </p:sp>
+      <p:sp>
+        <p:nvSpPr>
+          <p:cNvPr id="10" name="Rounded Rectangle 9"/>
           <p:cNvSpPr/>
           <p:nvPr/>
         </p:nvSpPr>
         <p:spPr>
           <a:xfrm>
-            <a:off x="3456432" y="1508760"/>
-            <a:ext cx="2560320" cy="73152"/>
-          </a:xfrm>
-          <a:prstGeom prst="rect">
-            <a:avLst/>
-          </a:prstGeom>
-          <a:solidFill>
-            <a:srgbClr val="14B8A6"/>
-          </a:solidFill>
-          <a:ln>
-            <a:noFill/>
+            <a:off x="6172200" y="4764024"/>
+            <a:ext cx="5285232" cy="1508760"/>
+          </a:xfrm>
+          <a:prstGeom prst="roundRect">
+            <a:avLst/>
+          </a:prstGeom>
+          <a:solidFill>
+            <a:srgbClr val="131A2A"/>
+          </a:solidFill>
+          <a:ln w="19050">
+            <a:solidFill>
+              <a:srgbClr val="10B981"/>
+            </a:solidFill>
           </a:ln>
         </p:spPr>
         <p:style>
@@ -5466,254 +5484,49 @@
           </a:fontRef>
         </p:style>
         <p:txBody>
-          <a:bodyPr rtlCol="0" anchor="ctr"/>
-          <a:lstStyle/>
-          <a:p>
-            <a:pPr algn="ctr"/>
-          </a:p>
-        </p:txBody>
-      </p:sp>
-      <p:sp>
-        <p:nvSpPr>
-          <p:cNvPr id="11" name="Rounded Rectangle 10"/>
-          <p:cNvSpPr/>
-          <p:nvPr/>
-        </p:nvSpPr>
-        <p:spPr>
-          <a:xfrm>
-            <a:off x="6181344" y="1508760"/>
-            <a:ext cx="2560320" cy="4892040"/>
-          </a:xfrm>
-          <a:prstGeom prst="roundRect">
-            <a:avLst/>
-          </a:prstGeom>
-          <a:solidFill>
-            <a:srgbClr val="131A2A"/>
-          </a:solidFill>
-          <a:ln w="12700">
-            <a:solidFill>
-              <a:srgbClr val="27324B"/>
-            </a:solidFill>
-          </a:ln>
-        </p:spPr>
-        <p:style>
-          <a:lnRef idx="1">
-            <a:schemeClr val="accent1"/>
-          </a:lnRef>
-          <a:fillRef idx="3">
-            <a:schemeClr val="accent1"/>
-          </a:fillRef>
-          <a:effectRef idx="2">
-            <a:schemeClr val="accent1"/>
-          </a:effectRef>
-          <a:fontRef idx="minor">
-            <a:schemeClr val="lt1"/>
-          </a:fontRef>
-        </p:style>
-        <p:txBody>
           <a:bodyPr rtlCol="0" anchor="ctr" wrap="square"/>
           <a:lstStyle/>
           <a:p>
             <a:pPr algn="ctr">
-              <a:defRPr sz="1200" b="1">
-                <a:solidFill>
-                  <a:srgbClr val="FFFFFF"/>
-                </a:solidFill>
-              </a:defRPr>
-            </a:pPr>
-            <a:r>
-              <a:t>👤 2D Anatomical Body Map</a:t>
+              <a:defRPr sz="1300" b="1">
+                <a:solidFill>
+                  <a:srgbClr val="10B981"/>
+                </a:solidFill>
+              </a:defRPr>
+            </a:pPr>
+            <a:r>
+              <a:t>🟢 GREEN — ROUTINE (P3)</a:t>
             </a:r>
           </a:p>
           <a:p>
             <a:pPr>
               <a:spcBef>
-                <a:spcPts val="800"/>
+                <a:spcPts val="200"/>
+              </a:spcBef>
+              <a:defRPr sz="1000" b="1">
+                <a:solidFill>
+                  <a:srgbClr val="FFFFFF"/>
+                </a:solidFill>
+              </a:defRPr>
+            </a:pPr>
+            <a:r>
+              <a:t>Queue SLA: Standard Outpatient Queue Consultation</a:t>
+            </a:r>
+          </a:p>
+          <a:p>
+            <a:pPr>
+              <a:spcBef>
+                <a:spcPts val="300"/>
               </a:spcBef>
               <a:defRPr sz="950">
                 <a:solidFill>
-                  <a:srgbClr val="F1F5F9"/>
-                </a:solidFill>
-              </a:defRPr>
-            </a:pPr>
-            <a:r>
-              <a:t>• Visual symptom selector for non-literate patients:</a:t>
-            </a:r>
-            <a:br/>
-            <a:r>
-              <a:t>• Head/Neuro, Chest/Cardiac, Lungs/Dyspnea, Abdomen, Limbs/Edema, Skin/Rashes</a:t>
-            </a:r>
-            <a:br/>
-            <a:r>
-              <a:t>• Clicking body zones automatically suggests corresponding clinical symptoms</a:t>
-            </a:r>
-            <a:br/>
-            <a:r>
-              <a:t>• Bridges language and literacy barriers in rural health camps.</a:t>
-            </a:r>
-          </a:p>
-        </p:txBody>
-      </p:sp>
-      <p:sp>
-        <p:nvSpPr>
-          <p:cNvPr id="12" name="Rectangle 11"/>
-          <p:cNvSpPr/>
-          <p:nvPr/>
-        </p:nvSpPr>
-        <p:spPr>
-          <a:xfrm>
-            <a:off x="6181344" y="1508760"/>
-            <a:ext cx="2560320" cy="73152"/>
-          </a:xfrm>
-          <a:prstGeom prst="rect">
-            <a:avLst/>
-          </a:prstGeom>
-          <a:solidFill>
-            <a:srgbClr val="14B8A6"/>
-          </a:solidFill>
-          <a:ln>
-            <a:noFill/>
-          </a:ln>
-        </p:spPr>
-        <p:style>
-          <a:lnRef idx="1">
-            <a:schemeClr val="accent1"/>
-          </a:lnRef>
-          <a:fillRef idx="3">
-            <a:schemeClr val="accent1"/>
-          </a:fillRef>
-          <a:effectRef idx="2">
-            <a:schemeClr val="accent1"/>
-          </a:effectRef>
-          <a:fontRef idx="minor">
-            <a:schemeClr val="lt1"/>
-          </a:fontRef>
-        </p:style>
-        <p:txBody>
-          <a:bodyPr rtlCol="0" anchor="ctr"/>
-          <a:lstStyle/>
-          <a:p>
-            <a:pPr algn="ctr"/>
-          </a:p>
-        </p:txBody>
-      </p:sp>
-      <p:sp>
-        <p:nvSpPr>
-          <p:cNvPr id="13" name="Rounded Rectangle 12"/>
-          <p:cNvSpPr/>
-          <p:nvPr/>
-        </p:nvSpPr>
-        <p:spPr>
-          <a:xfrm>
-            <a:off x="8906256" y="1508760"/>
-            <a:ext cx="2560320" cy="4892040"/>
-          </a:xfrm>
-          <a:prstGeom prst="roundRect">
-            <a:avLst/>
-          </a:prstGeom>
-          <a:solidFill>
-            <a:srgbClr val="131A2A"/>
-          </a:solidFill>
-          <a:ln w="12700">
-            <a:solidFill>
-              <a:srgbClr val="27324B"/>
-            </a:solidFill>
-          </a:ln>
-        </p:spPr>
-        <p:style>
-          <a:lnRef idx="1">
-            <a:schemeClr val="accent1"/>
-          </a:lnRef>
-          <a:fillRef idx="3">
-            <a:schemeClr val="accent1"/>
-          </a:fillRef>
-          <a:effectRef idx="2">
-            <a:schemeClr val="accent1"/>
-          </a:effectRef>
-          <a:fontRef idx="minor">
-            <a:schemeClr val="lt1"/>
-          </a:fontRef>
-        </p:style>
-        <p:txBody>
-          <a:bodyPr rtlCol="0" anchor="ctr" wrap="square"/>
-          <a:lstStyle/>
-          <a:p>
-            <a:pPr algn="ctr">
-              <a:defRPr sz="1200" b="1">
-                <a:solidFill>
-                  <a:srgbClr val="FFFFFF"/>
-                </a:solidFill>
-              </a:defRPr>
-            </a:pPr>
-            <a:r>
-              <a:t>📑 Single-Call Multimodal OCR</a:t>
-            </a:r>
-          </a:p>
-          <a:p>
-            <a:pPr>
-              <a:spcBef>
-                <a:spcPts val="800"/>
-              </a:spcBef>
-              <a:defRPr sz="950">
-                <a:solidFill>
-                  <a:srgbClr val="F1F5F9"/>
-                </a:solidFill>
-              </a:defRPr>
-            </a:pPr>
-            <a:r>
-              <a:t>• Document extraction via Gemini 2.5 Flash in a single API call:</a:t>
-            </a:r>
-            <a:br/>
-            <a:r>
-              <a:t>• Reads quantitative values from CBC reports (Platelets 85k), ECG slips (LVH strain pattern), prescriptions</a:t>
-            </a:r>
-            <a:br/>
-            <a:r>
-              <a:t>• Tags non-diagnostic supporting photos of pedal edema and rashes.</a:t>
-            </a:r>
-          </a:p>
-        </p:txBody>
-      </p:sp>
-      <p:sp>
-        <p:nvSpPr>
-          <p:cNvPr id="14" name="Rectangle 13"/>
-          <p:cNvSpPr/>
-          <p:nvPr/>
-        </p:nvSpPr>
-        <p:spPr>
-          <a:xfrm>
-            <a:off x="8906256" y="1508760"/>
-            <a:ext cx="2560320" cy="73152"/>
-          </a:xfrm>
-          <a:prstGeom prst="rect">
-            <a:avLst/>
-          </a:prstGeom>
-          <a:solidFill>
-            <a:srgbClr val="14B8A6"/>
-          </a:solidFill>
-          <a:ln>
-            <a:noFill/>
-          </a:ln>
-        </p:spPr>
-        <p:style>
-          <a:lnRef idx="1">
-            <a:schemeClr val="accent1"/>
-          </a:lnRef>
-          <a:fillRef idx="3">
-            <a:schemeClr val="accent1"/>
-          </a:fillRef>
-          <a:effectRef idx="2">
-            <a:schemeClr val="accent1"/>
-          </a:effectRef>
-          <a:fontRef idx="minor">
-            <a:schemeClr val="lt1"/>
-          </a:fontRef>
-        </p:style>
-        <p:txBody>
-          <a:bodyPr rtlCol="0" anchor="ctr"/>
-          <a:lstStyle/>
-          <a:p>
-            <a:pPr algn="ctr"/>
+                  <a:srgbClr val="94A3B8"/>
+                </a:solidFill>
+              </a:defRPr>
+            </a:pPr>
+            <a:r>
+              <a:t>Clinical Triggers: SpO2 &gt;= 94% • Baseline Stable Vitals • Mild Tension Headache • Chronic Medication Refill • Minor Cold/Cough</a:t>
+            </a:r>
           </a:p>
         </p:txBody>
       </p:sp>
@@ -5907,7 +5720,7 @@
               </a:defRPr>
             </a:pPr>
             <a:r>
-              <a:t>Doctor Command Dashboard &amp; Human-in-the-Loop Governance</a:t>
+              <a:t>Multimodal Ingestion: Voice, Vision, Vitals &amp; Vernacular Dialects</a:t>
             </a:r>
           </a:p>
         </p:txBody>
@@ -5964,7 +5777,7 @@
         <p:spPr>
           <a:xfrm>
             <a:off x="731520" y="1508760"/>
-            <a:ext cx="5852160" cy="4892040"/>
+            <a:ext cx="2560320" cy="4892040"/>
           </a:xfrm>
           <a:prstGeom prst="roundRect">
             <a:avLst/>
@@ -5972,9 +5785,9 @@
           <a:solidFill>
             <a:srgbClr val="131A2A"/>
           </a:solidFill>
-          <a:ln w="19050">
+          <a:ln w="12700">
             <a:solidFill>
-              <a:srgbClr val="14B8A6"/>
+              <a:srgbClr val="27324B"/>
             </a:solidFill>
           </a:ln>
         </p:spPr>
@@ -5997,178 +5810,106 @@
           <a:lstStyle/>
           <a:p>
             <a:pPr algn="ctr">
-              <a:defRPr sz="1400" b="1">
-                <a:solidFill>
-                  <a:srgbClr val="38BDF8"/>
-                </a:solidFill>
-              </a:defRPr>
-            </a:pPr>
-            <a:r>
-              <a:t>🏥 HOSPITAL LIVE TRIAGE COMMAND CENTER</a:t>
+              <a:defRPr sz="1200" b="1">
+                <a:solidFill>
+                  <a:srgbClr val="FFFFFF"/>
+                </a:solidFill>
+              </a:defRPr>
+            </a:pPr>
+            <a:r>
+              <a:t>🗣️ Vernacular Dialect Normalizer</a:t>
             </a:r>
           </a:p>
           <a:p>
             <a:pPr>
               <a:spcBef>
-                <a:spcPts val="200"/>
+                <a:spcPts val="800"/>
               </a:spcBef>
               <a:defRPr sz="950">
                 <a:solidFill>
-                  <a:srgbClr val="94A3B8"/>
-                </a:solidFill>
-              </a:defRPr>
-            </a:pPr>
-            <a:r>
-              <a:t>Bed Telemetry: Emergency Bays: 3/5 Available • Doctors On Duty: 5 • Active Waiting: 6</a:t>
-            </a:r>
-          </a:p>
-          <a:p>
-            <a:pPr>
-              <a:spcBef>
-                <a:spcPts val="600"/>
-              </a:spcBef>
-              <a:defRPr sz="1000" b="1">
-                <a:solidFill>
-                  <a:srgbClr val="F43F5E"/>
-                </a:solidFill>
-              </a:defRPr>
-            </a:pPr>
-            <a:r>
-              <a:t>🔴 RED LANE (Immediate Emergency Care)</a:t>
-            </a:r>
-          </a:p>
-          <a:p>
-            <a:pPr>
-              <a:defRPr sz="900">
-                <a:solidFill>
                   <a:srgbClr val="F1F5F9"/>
                 </a:solidFill>
               </a:defRPr>
             </a:pPr>
             <a:r>
-              <a:t>   T-024 • Ramesh K. (62M) • SpO2 89% • Crushing Chest Pain • Wait: 1m</a:t>
-            </a:r>
-          </a:p>
-          <a:p>
-            <a:pPr>
-              <a:spcBef>
-                <a:spcPts val="600"/>
-              </a:spcBef>
-              <a:defRPr sz="1000" b="1">
-                <a:solidFill>
-                  <a:srgbClr val="F43F5E"/>
-                </a:solidFill>
-              </a:defRPr>
-            </a:pPr>
-            <a:r>
-              <a:t>🔴 RED LANE (Maternal Pre-eclampsia)</a:t>
-            </a:r>
-          </a:p>
-          <a:p>
-            <a:pPr>
-              <a:defRPr sz="900">
-                <a:solidFill>
-                  <a:srgbClr val="F1F5F9"/>
-                </a:solidFill>
-              </a:defRPr>
-            </a:pPr>
-            <a:r>
-              <a:t>   T-019 • Meena D. (28F) • BP 168/110 • 34w Gestation • Wait: 3m</a:t>
-            </a:r>
-          </a:p>
-          <a:p>
-            <a:pPr>
-              <a:spcBef>
-                <a:spcPts val="600"/>
-              </a:spcBef>
-              <a:defRPr sz="1000" b="1">
-                <a:solidFill>
-                  <a:srgbClr val="F59E0B"/>
-                </a:solidFill>
-              </a:defRPr>
-            </a:pPr>
-            <a:r>
-              <a:t>🟠 YELLOW LANE (Priority Outpatient)</a:t>
-            </a:r>
-          </a:p>
-          <a:p>
-            <a:pPr>
-              <a:defRPr sz="900">
-                <a:solidFill>
-                  <a:srgbClr val="F1F5F9"/>
-                </a:solidFill>
-              </a:defRPr>
-            </a:pPr>
-            <a:r>
-              <a:t>   T-025 • Priya S. (34F) • Temp 102.8°F • CBC Platelets 85k • Wait: 7m</a:t>
-            </a:r>
-          </a:p>
-          <a:p>
-            <a:pPr>
-              <a:spcBef>
-                <a:spcPts val="600"/>
-              </a:spcBef>
-              <a:defRPr sz="1000" b="1">
-                <a:solidFill>
-                  <a:srgbClr val="F59E0B"/>
-                </a:solidFill>
-              </a:defRPr>
-            </a:pPr>
-            <a:r>
-              <a:t>🟠 YELLOW LANE (Occupational Screening)</a:t>
-            </a:r>
-          </a:p>
-          <a:p>
-            <a:pPr>
-              <a:defRPr sz="900">
-                <a:solidFill>
-                  <a:srgbClr val="F1F5F9"/>
-                </a:solidFill>
-              </a:defRPr>
-            </a:pPr>
-            <a:r>
-              <a:t>   T-027 • Rajesh M. (45M) • Paradeep Chemical Inhalation • Wait: 9m</a:t>
-            </a:r>
-          </a:p>
-          <a:p>
-            <a:pPr>
-              <a:spcBef>
-                <a:spcPts val="600"/>
-              </a:spcBef>
-              <a:defRPr sz="1000" b="1">
-                <a:solidFill>
-                  <a:srgbClr val="10B981"/>
-                </a:solidFill>
-              </a:defRPr>
-            </a:pPr>
-            <a:r>
-              <a:t>🟢 GREEN LANE (Routine Consultation)</a:t>
-            </a:r>
-          </a:p>
-          <a:p>
-            <a:pPr>
-              <a:defRPr sz="900">
-                <a:solidFill>
-                  <a:srgbClr val="F1F5F9"/>
-                </a:solidFill>
-              </a:defRPr>
-            </a:pPr>
-            <a:r>
-              <a:t>   T-026 • Subhash P. (24M) • Mild Study Tension Headache • Wait: 12m</a:t>
-            </a:r>
-          </a:p>
-        </p:txBody>
-      </p:sp>
-      <p:sp>
-        <p:nvSpPr>
-          <p:cNvPr id="8" name="Rounded Rectangle 7"/>
+              <a:t>• Solves Indian cultural idiom gap by mapping to SNOMED-CT &amp; ICD-10:</a:t>
+            </a:r>
+            <a:br/>
+            <a:r>
+              <a:t>  - 'ଛାତି ଫାଟିଯିବା' ➔ Severe Stabbing Chest Pain [ALERT]</a:t>
+            </a:r>
+            <a:br/>
+            <a:r>
+              <a:t>  - 'ପଥର ଭଳି ଭାରି' ➔ Crushing Chest Heaviness [ALERT]</a:t>
+            </a:r>
+            <a:br/>
+            <a:r>
+              <a:t>  - 'ଝାଳରେ ଥଣ୍ଡା' ➔ Cold Diaphoresis / Shock Sign [ALERT]</a:t>
+            </a:r>
+            <a:br/>
+            <a:r>
+              <a:t>  - '୨ ଘଣ୍ଟା ହେଲା' ➔ Acute Onset (2 hours ago)</a:t>
+            </a:r>
+            <a:br/>
+            <a:r>
+              <a:t>• Preserves exact spoken voice for legal records while outputting clinical English for doctors.</a:t>
+            </a:r>
+          </a:p>
+        </p:txBody>
+      </p:sp>
+      <p:sp>
+        <p:nvSpPr>
+          <p:cNvPr id="8" name="Rectangle 7"/>
           <p:cNvSpPr/>
           <p:nvPr/>
         </p:nvSpPr>
         <p:spPr>
           <a:xfrm>
-            <a:off x="6812280" y="1508760"/>
-            <a:ext cx="4645152" cy="4892040"/>
+            <a:off x="731520" y="1508760"/>
+            <a:ext cx="2560320" cy="73152"/>
+          </a:xfrm>
+          <a:prstGeom prst="rect">
+            <a:avLst/>
+          </a:prstGeom>
+          <a:solidFill>
+            <a:srgbClr val="14B8A6"/>
+          </a:solidFill>
+          <a:ln>
+            <a:noFill/>
+          </a:ln>
+        </p:spPr>
+        <p:style>
+          <a:lnRef idx="1">
+            <a:schemeClr val="accent1"/>
+          </a:lnRef>
+          <a:fillRef idx="3">
+            <a:schemeClr val="accent1"/>
+          </a:fillRef>
+          <a:effectRef idx="2">
+            <a:schemeClr val="accent1"/>
+          </a:effectRef>
+          <a:fontRef idx="minor">
+            <a:schemeClr val="lt1"/>
+          </a:fontRef>
+        </p:style>
+        <p:txBody>
+          <a:bodyPr rtlCol="0" anchor="ctr"/>
+          <a:lstStyle/>
+          <a:p>
+            <a:pPr algn="ctr"/>
+          </a:p>
+        </p:txBody>
+      </p:sp>
+      <p:sp>
+        <p:nvSpPr>
+          <p:cNvPr id="9" name="Rounded Rectangle 8"/>
+          <p:cNvSpPr/>
+          <p:nvPr/>
+        </p:nvSpPr>
+        <p:spPr>
+          <a:xfrm>
+            <a:off x="3456432" y="1508760"/>
+            <a:ext cx="2560320" cy="4892040"/>
           </a:xfrm>
           <a:prstGeom prst="roundRect">
             <a:avLst/>
@@ -6201,20 +5942,20 @@
           <a:lstStyle/>
           <a:p>
             <a:pPr algn="ctr">
-              <a:defRPr sz="1400" b="1">
+              <a:defRPr sz="1200" b="1">
                 <a:solidFill>
                   <a:srgbClr val="FFFFFF"/>
                 </a:solidFill>
               </a:defRPr>
             </a:pPr>
             <a:r>
-              <a:t>⚖️ Human-in-the-Loop Safeguards (15% Rubric)</a:t>
+              <a:t>🪪 Holographic ABDM / ABHA Sync</a:t>
             </a:r>
           </a:p>
           <a:p>
             <a:pPr>
               <a:spcBef>
-                <a:spcPts val="600"/>
+                <a:spcPts val="800"/>
               </a:spcBef>
               <a:defRPr sz="950">
                 <a:solidFill>
@@ -6223,13 +5964,122 @@
               </a:defRPr>
             </a:pPr>
             <a:r>
-              <a:t>1. Doctor Verification Drawer: Reviewing Medical Officer (MO) reviews the structured timeline, missing information gaps, and raw voice statement before patient enters.</a:t>
+              <a:t>• Ayushman Bharat Digital Mission (ABDM) Integration:</a:t>
+            </a:r>
+            <a:br/>
+            <a:r>
+              <a:t>• 1-Click mock QR scan fetches verified ABHA ID (e.g. 91-4821-9923-0192)</a:t>
+            </a:r>
+            <a:br/>
+            <a:r>
+              <a:t>• Instantly pulls synced longitudinal medical history (Hypertension 5y, Type 2 Diabetes)</a:t>
+            </a:r>
+            <a:br/>
+            <a:r>
+              <a:t>• Highlights critical drug allergy alerts (Penicillin Anaphylaxis) before nurse enters symptoms.</a:t>
+            </a:r>
+          </a:p>
+        </p:txBody>
+      </p:sp>
+      <p:sp>
+        <p:nvSpPr>
+          <p:cNvPr id="10" name="Rectangle 9"/>
+          <p:cNvSpPr/>
+          <p:nvPr/>
+        </p:nvSpPr>
+        <p:spPr>
+          <a:xfrm>
+            <a:off x="3456432" y="1508760"/>
+            <a:ext cx="2560320" cy="73152"/>
+          </a:xfrm>
+          <a:prstGeom prst="rect">
+            <a:avLst/>
+          </a:prstGeom>
+          <a:solidFill>
+            <a:srgbClr val="14B8A6"/>
+          </a:solidFill>
+          <a:ln>
+            <a:noFill/>
+          </a:ln>
+        </p:spPr>
+        <p:style>
+          <a:lnRef idx="1">
+            <a:schemeClr val="accent1"/>
+          </a:lnRef>
+          <a:fillRef idx="3">
+            <a:schemeClr val="accent1"/>
+          </a:fillRef>
+          <a:effectRef idx="2">
+            <a:schemeClr val="accent1"/>
+          </a:effectRef>
+          <a:fontRef idx="minor">
+            <a:schemeClr val="lt1"/>
+          </a:fontRef>
+        </p:style>
+        <p:txBody>
+          <a:bodyPr rtlCol="0" anchor="ctr"/>
+          <a:lstStyle/>
+          <a:p>
+            <a:pPr algn="ctr"/>
+          </a:p>
+        </p:txBody>
+      </p:sp>
+      <p:sp>
+        <p:nvSpPr>
+          <p:cNvPr id="11" name="Rounded Rectangle 10"/>
+          <p:cNvSpPr/>
+          <p:nvPr/>
+        </p:nvSpPr>
+        <p:spPr>
+          <a:xfrm>
+            <a:off x="6181344" y="1508760"/>
+            <a:ext cx="2560320" cy="4892040"/>
+          </a:xfrm>
+          <a:prstGeom prst="roundRect">
+            <a:avLst/>
+          </a:prstGeom>
+          <a:solidFill>
+            <a:srgbClr val="131A2A"/>
+          </a:solidFill>
+          <a:ln w="12700">
+            <a:solidFill>
+              <a:srgbClr val="27324B"/>
+            </a:solidFill>
+          </a:ln>
+        </p:spPr>
+        <p:style>
+          <a:lnRef idx="1">
+            <a:schemeClr val="accent1"/>
+          </a:lnRef>
+          <a:fillRef idx="3">
+            <a:schemeClr val="accent1"/>
+          </a:fillRef>
+          <a:effectRef idx="2">
+            <a:schemeClr val="accent1"/>
+          </a:effectRef>
+          <a:fontRef idx="minor">
+            <a:schemeClr val="lt1"/>
+          </a:fontRef>
+        </p:style>
+        <p:txBody>
+          <a:bodyPr rtlCol="0" anchor="ctr" wrap="square"/>
+          <a:lstStyle/>
+          <a:p>
+            <a:pPr algn="ctr">
+              <a:defRPr sz="1200" b="1">
+                <a:solidFill>
+                  <a:srgbClr val="FFFFFF"/>
+                </a:solidFill>
+              </a:defRPr>
+            </a:pPr>
+            <a:r>
+              <a:t>👤 2D Anatomical Body Map</a:t>
             </a:r>
           </a:p>
           <a:p>
             <a:pPr>
               <a:spcBef>
-                <a:spcPts val="600"/>
+                <a:spcPts val="800"/>
               </a:spcBef>
               <a:defRPr sz="950">
                 <a:solidFill>
@@ -6238,13 +6088,122 @@
               </a:defRPr>
             </a:pPr>
             <a:r>
-              <a:t>2. 1-Click Priority Override: Doctor can upgrade (e.g. YELLOW to RED) or downgrade priority with complete clinical freedom.</a:t>
+              <a:t>• Visual symptom selector for non-literate patients:</a:t>
+            </a:r>
+            <a:br/>
+            <a:r>
+              <a:t>• Head/Neuro, Chest/Cardiac, Lungs/Dyspnea, Abdomen, Limbs/Edema, Skin/Rashes</a:t>
+            </a:r>
+            <a:br/>
+            <a:r>
+              <a:t>• Clicking body zones automatically suggests corresponding clinical symptoms</a:t>
+            </a:r>
+            <a:br/>
+            <a:r>
+              <a:t>• Bridges language and literacy barriers in rural health camps.</a:t>
+            </a:r>
+          </a:p>
+        </p:txBody>
+      </p:sp>
+      <p:sp>
+        <p:nvSpPr>
+          <p:cNvPr id="12" name="Rectangle 11"/>
+          <p:cNvSpPr/>
+          <p:nvPr/>
+        </p:nvSpPr>
+        <p:spPr>
+          <a:xfrm>
+            <a:off x="6181344" y="1508760"/>
+            <a:ext cx="2560320" cy="73152"/>
+          </a:xfrm>
+          <a:prstGeom prst="rect">
+            <a:avLst/>
+          </a:prstGeom>
+          <a:solidFill>
+            <a:srgbClr val="14B8A6"/>
+          </a:solidFill>
+          <a:ln>
+            <a:noFill/>
+          </a:ln>
+        </p:spPr>
+        <p:style>
+          <a:lnRef idx="1">
+            <a:schemeClr val="accent1"/>
+          </a:lnRef>
+          <a:fillRef idx="3">
+            <a:schemeClr val="accent1"/>
+          </a:fillRef>
+          <a:effectRef idx="2">
+            <a:schemeClr val="accent1"/>
+          </a:effectRef>
+          <a:fontRef idx="minor">
+            <a:schemeClr val="lt1"/>
+          </a:fontRef>
+        </p:style>
+        <p:txBody>
+          <a:bodyPr rtlCol="0" anchor="ctr"/>
+          <a:lstStyle/>
+          <a:p>
+            <a:pPr algn="ctr"/>
+          </a:p>
+        </p:txBody>
+      </p:sp>
+      <p:sp>
+        <p:nvSpPr>
+          <p:cNvPr id="13" name="Rounded Rectangle 12"/>
+          <p:cNvSpPr/>
+          <p:nvPr/>
+        </p:nvSpPr>
+        <p:spPr>
+          <a:xfrm>
+            <a:off x="8906256" y="1508760"/>
+            <a:ext cx="2560320" cy="4892040"/>
+          </a:xfrm>
+          <a:prstGeom prst="roundRect">
+            <a:avLst/>
+          </a:prstGeom>
+          <a:solidFill>
+            <a:srgbClr val="131A2A"/>
+          </a:solidFill>
+          <a:ln w="12700">
+            <a:solidFill>
+              <a:srgbClr val="27324B"/>
+            </a:solidFill>
+          </a:ln>
+        </p:spPr>
+        <p:style>
+          <a:lnRef idx="1">
+            <a:schemeClr val="accent1"/>
+          </a:lnRef>
+          <a:fillRef idx="3">
+            <a:schemeClr val="accent1"/>
+          </a:fillRef>
+          <a:effectRef idx="2">
+            <a:schemeClr val="accent1"/>
+          </a:effectRef>
+          <a:fontRef idx="minor">
+            <a:schemeClr val="lt1"/>
+          </a:fontRef>
+        </p:style>
+        <p:txBody>
+          <a:bodyPr rtlCol="0" anchor="ctr" wrap="square"/>
+          <a:lstStyle/>
+          <a:p>
+            <a:pPr algn="ctr">
+              <a:defRPr sz="1200" b="1">
+                <a:solidFill>
+                  <a:srgbClr val="FFFFFF"/>
+                </a:solidFill>
+              </a:defRPr>
+            </a:pPr>
+            <a:r>
+              <a:t>📑 Single-Call Multimodal OCR</a:t>
             </a:r>
           </a:p>
           <a:p>
             <a:pPr>
               <a:spcBef>
-                <a:spcPts val="600"/>
+                <a:spcPts val="800"/>
               </a:spcBef>
               <a:defRPr sz="950">
                 <a:solidFill>
@@ -6253,38 +6212,59 @@
               </a:defRPr>
             </a:pPr>
             <a:r>
-              <a:t>3. Mandatory Clinical Justification: System forces clinician to enter reason (e.g. 'Repeat SpO2 is 97% on warm finger; chest tenderness is reproducible muscular strain').</a:t>
-            </a:r>
-          </a:p>
-          <a:p>
-            <a:pPr>
-              <a:spcBef>
-                <a:spcPts val="600"/>
-              </a:spcBef>
-              <a:defRPr sz="950">
-                <a:solidFill>
-                  <a:srgbClr val="F1F5F9"/>
-                </a:solidFill>
-              </a:defRPr>
-            </a:pPr>
-            <a:r>
-              <a:t>4. Immutable Audit Trail: Every decision records Reviewer ID (e.g. DR-MO-402), timestamp, AI original priority vs. final clinician priority for clinical accountability.</a:t>
-            </a:r>
-          </a:p>
-          <a:p>
-            <a:pPr>
-              <a:spcBef>
-                <a:spcPts val="600"/>
-              </a:spcBef>
-              <a:defRPr sz="950">
-                <a:solidFill>
-                  <a:srgbClr val="F1F5F9"/>
-                </a:solidFill>
-              </a:defRPr>
-            </a:pPr>
-            <a:r>
-              <a:t>5. Dynamic Follow-Up Questions: Presents 3 high-yield questions in Odia/Hindi for nurse to ask at bedside.</a:t>
-            </a:r>
+              <a:t>• Document extraction via Gemini 2.5 Flash in a single API call:</a:t>
+            </a:r>
+            <a:br/>
+            <a:r>
+              <a:t>• Reads quantitative values from CBC reports (Platelets 85k), ECG slips (LVH strain pattern), prescriptions</a:t>
+            </a:r>
+            <a:br/>
+            <a:r>
+              <a:t>• Tags non-diagnostic supporting photos of pedal edema and rashes.</a:t>
+            </a:r>
+          </a:p>
+        </p:txBody>
+      </p:sp>
+      <p:sp>
+        <p:nvSpPr>
+          <p:cNvPr id="14" name="Rectangle 13"/>
+          <p:cNvSpPr/>
+          <p:nvPr/>
+        </p:nvSpPr>
+        <p:spPr>
+          <a:xfrm>
+            <a:off x="8906256" y="1508760"/>
+            <a:ext cx="2560320" cy="73152"/>
+          </a:xfrm>
+          <a:prstGeom prst="rect">
+            <a:avLst/>
+          </a:prstGeom>
+          <a:solidFill>
+            <a:srgbClr val="14B8A6"/>
+          </a:solidFill>
+          <a:ln>
+            <a:noFill/>
+          </a:ln>
+        </p:spPr>
+        <p:style>
+          <a:lnRef idx="1">
+            <a:schemeClr val="accent1"/>
+          </a:lnRef>
+          <a:fillRef idx="3">
+            <a:schemeClr val="accent1"/>
+          </a:fillRef>
+          <a:effectRef idx="2">
+            <a:schemeClr val="accent1"/>
+          </a:effectRef>
+          <a:fontRef idx="minor">
+            <a:schemeClr val="lt1"/>
+          </a:fontRef>
+        </p:style>
+        <p:txBody>
+          <a:bodyPr rtlCol="0" anchor="ctr"/>
+          <a:lstStyle/>
+          <a:p>
+            <a:pPr algn="ctr"/>
           </a:p>
         </p:txBody>
       </p:sp>
@@ -6478,7 +6458,7 @@
               </a:defRPr>
             </a:pPr>
             <a:r>
-              <a:t>Odisha Public Health Network &amp; Official NHM Referral Engine</a:t>
+              <a:t>Doctor Command Dashboard &amp; Human-in-the-Loop Governance</a:t>
             </a:r>
           </a:p>
         </p:txBody>
@@ -6535,7 +6515,7 @@
         <p:spPr>
           <a:xfrm>
             <a:off x="731520" y="1508760"/>
-            <a:ext cx="10728655" cy="1691640"/>
+            <a:ext cx="5852160" cy="4892040"/>
           </a:xfrm>
           <a:prstGeom prst="roundRect">
             <a:avLst/>
@@ -6543,7 +6523,7 @@
           <a:solidFill>
             <a:srgbClr val="131A2A"/>
           </a:solidFill>
-          <a:ln>
+          <a:ln w="19050">
             <a:solidFill>
               <a:srgbClr val="14B8A6"/>
             </a:solidFill>
@@ -6568,53 +6548,164 @@
           <a:lstStyle/>
           <a:p>
             <a:pPr algn="ctr">
-              <a:defRPr sz="1300" b="1">
+              <a:defRPr sz="1400" b="1">
                 <a:solidFill>
                   <a:srgbClr val="38BDF8"/>
                 </a:solidFill>
               </a:defRPr>
             </a:pPr>
             <a:r>
-              <a:t>🏛️ Complete 6-Tier All-India Facility Network (National Health Facility Registry / NIN Standard):</a:t>
+              <a:t>🏥 HOSPITAL LIVE TRIAGE COMMAND CENTER</a:t>
             </a:r>
           </a:p>
           <a:p>
             <a:pPr>
               <a:spcBef>
-                <a:spcPts val="400"/>
+                <a:spcPts val="200"/>
               </a:spcBef>
-              <a:defRPr sz="1000">
+              <a:defRPr sz="950">
+                <a:solidFill>
+                  <a:srgbClr val="94A3B8"/>
+                </a:solidFill>
+              </a:defRPr>
+            </a:pPr>
+            <a:r>
+              <a:t>Bed Telemetry: Emergency Bays: 3/5 Available • Doctors On Duty: 5 • Active Waiting: 6</a:t>
+            </a:r>
+          </a:p>
+          <a:p>
+            <a:pPr>
+              <a:spcBef>
+                <a:spcPts val="600"/>
+              </a:spcBef>
+              <a:defRPr sz="1000" b="1">
+                <a:solidFill>
+                  <a:srgbClr val="F43F5E"/>
+                </a:solidFill>
+              </a:defRPr>
+            </a:pPr>
+            <a:r>
+              <a:t>🔴 RED LANE (Immediate Emergency Care)</a:t>
+            </a:r>
+          </a:p>
+          <a:p>
+            <a:pPr>
+              <a:defRPr sz="900">
                 <a:solidFill>
                   <a:srgbClr val="F1F5F9"/>
                 </a:solidFill>
               </a:defRPr>
             </a:pPr>
             <a:r>
-              <a:t>• PHC Jatni, Khordha (OD-KHD-PHC-102) ➔ Rural First-Line Triage</a:t>
-            </a:r>
-            <a:br/>
-            <a:r>
-              <a:t>• CHC Tangi, Khordha (OD-KHD-CHC-204) ➔ Block-Level Community Health Center</a:t>
-            </a:r>
-            <a:br/>
-            <a:r>
-              <a:t>• Capital Hospital, Bhubaneswar (OD-DHH-401) ➔ 750-Bed District Headquarter Hospital</a:t>
-            </a:r>
-            <a:br/>
-            <a:r>
-              <a:t>• SCB Medical College, Cuttack (OD-MCH-001) ➔ Apex Tertiary Emergency &amp; Trauma Bay</a:t>
-            </a:r>
-            <a:br/>
-            <a:r>
-              <a:t>• Paradeep Industrial Unit (OD-JSP-IEH-301) ➔ Industrial Port Trust Occupational Screening</a:t>
-            </a:r>
-            <a:br/>
-            <a:r>
-              <a:t>• Koraput Mobile Health Camp (OD-KPT-MOBI-501) ➔ Tribal Health Mission Outreach</a:t>
-            </a:r>
-            <a:br/>
-            <a:r>
-              <a:t>• Flagship National Anchors: AIIMS New Delhi (DL-NDLS-AIIMS-001) &amp; Thane MIDC Maharashtra (MH-THN-MIDC-402)</a:t>
+              <a:t>   T-024 • Ramesh K. (62M) • SpO2 89% • Crushing Chest Pain • Wait: 1m</a:t>
+            </a:r>
+          </a:p>
+          <a:p>
+            <a:pPr>
+              <a:spcBef>
+                <a:spcPts val="600"/>
+              </a:spcBef>
+              <a:defRPr sz="1000" b="1">
+                <a:solidFill>
+                  <a:srgbClr val="F43F5E"/>
+                </a:solidFill>
+              </a:defRPr>
+            </a:pPr>
+            <a:r>
+              <a:t>🔴 RED LANE (Maternal Pre-eclampsia)</a:t>
+            </a:r>
+          </a:p>
+          <a:p>
+            <a:pPr>
+              <a:defRPr sz="900">
+                <a:solidFill>
+                  <a:srgbClr val="F1F5F9"/>
+                </a:solidFill>
+              </a:defRPr>
+            </a:pPr>
+            <a:r>
+              <a:t>   T-019 • Meena D. (28F) • BP 168/110 • 34w Gestation • Wait: 3m</a:t>
+            </a:r>
+          </a:p>
+          <a:p>
+            <a:pPr>
+              <a:spcBef>
+                <a:spcPts val="600"/>
+              </a:spcBef>
+              <a:defRPr sz="1000" b="1">
+                <a:solidFill>
+                  <a:srgbClr val="F59E0B"/>
+                </a:solidFill>
+              </a:defRPr>
+            </a:pPr>
+            <a:r>
+              <a:t>🟠 YELLOW LANE (Priority Outpatient)</a:t>
+            </a:r>
+          </a:p>
+          <a:p>
+            <a:pPr>
+              <a:defRPr sz="900">
+                <a:solidFill>
+                  <a:srgbClr val="F1F5F9"/>
+                </a:solidFill>
+              </a:defRPr>
+            </a:pPr>
+            <a:r>
+              <a:t>   T-025 • Priya S. (34F) • Temp 102.8°F • CBC Platelets 85k • Wait: 7m</a:t>
+            </a:r>
+          </a:p>
+          <a:p>
+            <a:pPr>
+              <a:spcBef>
+                <a:spcPts val="600"/>
+              </a:spcBef>
+              <a:defRPr sz="1000" b="1">
+                <a:solidFill>
+                  <a:srgbClr val="F59E0B"/>
+                </a:solidFill>
+              </a:defRPr>
+            </a:pPr>
+            <a:r>
+              <a:t>🟠 YELLOW LANE (Occupational Screening)</a:t>
+            </a:r>
+          </a:p>
+          <a:p>
+            <a:pPr>
+              <a:defRPr sz="900">
+                <a:solidFill>
+                  <a:srgbClr val="F1F5F9"/>
+                </a:solidFill>
+              </a:defRPr>
+            </a:pPr>
+            <a:r>
+              <a:t>   T-027 • Rajesh M. (45M) • Paradeep Chemical Inhalation • Wait: 9m</a:t>
+            </a:r>
+          </a:p>
+          <a:p>
+            <a:pPr>
+              <a:spcBef>
+                <a:spcPts val="600"/>
+              </a:spcBef>
+              <a:defRPr sz="1000" b="1">
+                <a:solidFill>
+                  <a:srgbClr val="10B981"/>
+                </a:solidFill>
+              </a:defRPr>
+            </a:pPr>
+            <a:r>
+              <a:t>🟢 GREEN LANE (Routine Consultation)</a:t>
+            </a:r>
+          </a:p>
+          <a:p>
+            <a:pPr>
+              <a:defRPr sz="900">
+                <a:solidFill>
+                  <a:srgbClr val="F1F5F9"/>
+                </a:solidFill>
+              </a:defRPr>
+            </a:pPr>
+            <a:r>
+              <a:t>   T-026 • Subhash P. (24M) • Mild Study Tension Headache • Wait: 12m</a:t>
             </a:r>
           </a:p>
         </p:txBody>
@@ -6627,18 +6718,18 @@
         </p:nvSpPr>
         <p:spPr>
           <a:xfrm>
-            <a:off x="731520" y="3383280"/>
-            <a:ext cx="10728655" cy="3017520"/>
+            <a:off x="6812280" y="1508760"/>
+            <a:ext cx="4645152" cy="4892040"/>
           </a:xfrm>
           <a:prstGeom prst="roundRect">
             <a:avLst/>
           </a:prstGeom>
           <a:solidFill>
-            <a:srgbClr val="1C121C"/>
-          </a:solidFill>
-          <a:ln w="19050">
+            <a:srgbClr val="131A2A"/>
+          </a:solidFill>
+          <a:ln w="12700">
             <a:solidFill>
-              <a:srgbClr val="F43F5E"/>
+              <a:srgbClr val="27324B"/>
             </a:solidFill>
           </a:ln>
         </p:spPr>
@@ -6661,14 +6752,14 @@
           <a:lstStyle/>
           <a:p>
             <a:pPr algn="ctr">
-              <a:defRPr sz="1200" b="1">
-                <a:solidFill>
-                  <a:srgbClr val="F43F5E"/>
-                </a:solidFill>
-              </a:defRPr>
-            </a:pPr>
-            <a:r>
-              <a:t>📄 GOVERNMENT OF ODISHA • HEALTH &amp; FAMILY WELFARE DEPARTMENT — NHM CLINICAL REFERRAL SLIP</a:t>
+              <a:defRPr sz="1400" b="1">
+                <a:solidFill>
+                  <a:srgbClr val="FFFFFF"/>
+                </a:solidFill>
+              </a:defRPr>
+            </a:pPr>
+            <a:r>
+              <a:t>⚖️ Human-in-the-Loop Safeguards (15% Rubric)</a:t>
             </a:r>
           </a:p>
           <a:p>
@@ -6676,42 +6767,74 @@
               <a:spcBef>
                 <a:spcPts val="600"/>
               </a:spcBef>
-              <a:defRPr sz="1000">
+              <a:defRPr sz="950">
                 <a:solidFill>
                   <a:srgbClr val="F1F5F9"/>
                 </a:solidFill>
               </a:defRPr>
             </a:pPr>
             <a:r>
-              <a:t>Referring Facility: Primary Health Center (PHC) Jatni, Khordha (NIN: OD-KHD-PHC-102)</a:t>
-            </a:r>
-            <a:br/>
-            <a:r>
-              <a:t>Referred To: Emergency Resuscitation Bay, Capital Hospital Bhubaneswar / SCB Medical College, Cuttack</a:t>
-            </a:r>
-            <a:br/>
-            <a:r>
-              <a:t>Patient: Ramesh K. | ABHA ID: 91-4821-9923-0192 | Token: T-024 | Age/Sex: 62y/Male</a:t>
-            </a:r>
-            <a:br/>
-            <a:r>
-              <a:t>Chief Complaint: Retrosternal crushing chest pain &amp; severe dyspnea (2 hours duration)</a:t>
-            </a:r>
-            <a:br/>
-            <a:r>
-              <a:t>Triage Classification: 🔴 RED PRIORITY (Immediate Medical Officer Assessment Required)</a:t>
-            </a:r>
-            <a:br/>
-            <a:r>
-              <a:t>Departure Vitals: SpO₂ 89% (Room Air), BP 158/96 mmHg, Pulse 112 bpm, RR 26/min, Temp 99.8°F</a:t>
-            </a:r>
-            <a:br/>
-            <a:r>
-              <a:t>Pre-Referral Stabilization: Oxygen initiated via nasal cannula at 4 L/min. Aspirin 300mg stat administered.</a:t>
-            </a:r>
-            <a:br/>
-            <a:r>
-              <a:t>Escort Logistics: 108 Emergency Ambulance Dispatched • Emergency Transfer Barcode Generated for Zero-Wait Reception</a:t>
+              <a:t>1. Doctor Verification Drawer: Reviewing Medical Officer (MO) reviews the structured timeline, missing information gaps, and raw voice statement before patient enters.</a:t>
+            </a:r>
+          </a:p>
+          <a:p>
+            <a:pPr>
+              <a:spcBef>
+                <a:spcPts val="600"/>
+              </a:spcBef>
+              <a:defRPr sz="950">
+                <a:solidFill>
+                  <a:srgbClr val="F1F5F9"/>
+                </a:solidFill>
+              </a:defRPr>
+            </a:pPr>
+            <a:r>
+              <a:t>2. 1-Click Priority Override: Doctor can upgrade (e.g. YELLOW to RED) or downgrade priority with complete clinical freedom.</a:t>
+            </a:r>
+          </a:p>
+          <a:p>
+            <a:pPr>
+              <a:spcBef>
+                <a:spcPts val="600"/>
+              </a:spcBef>
+              <a:defRPr sz="950">
+                <a:solidFill>
+                  <a:srgbClr val="F1F5F9"/>
+                </a:solidFill>
+              </a:defRPr>
+            </a:pPr>
+            <a:r>
+              <a:t>3. Mandatory Clinical Justification: System forces clinician to enter reason (e.g. 'Repeat SpO2 is 97% on warm finger; chest tenderness is reproducible muscular strain').</a:t>
+            </a:r>
+          </a:p>
+          <a:p>
+            <a:pPr>
+              <a:spcBef>
+                <a:spcPts val="600"/>
+              </a:spcBef>
+              <a:defRPr sz="950">
+                <a:solidFill>
+                  <a:srgbClr val="F1F5F9"/>
+                </a:solidFill>
+              </a:defRPr>
+            </a:pPr>
+            <a:r>
+              <a:t>4. Immutable Audit Trail: Every decision records Reviewer ID (e.g. DR-MO-402), timestamp, AI original priority vs. final clinician priority for clinical accountability.</a:t>
+            </a:r>
+          </a:p>
+          <a:p>
+            <a:pPr>
+              <a:spcBef>
+                <a:spcPts val="600"/>
+              </a:spcBef>
+              <a:defRPr sz="950">
+                <a:solidFill>
+                  <a:srgbClr val="F1F5F9"/>
+                </a:solidFill>
+              </a:defRPr>
+            </a:pPr>
+            <a:r>
+              <a:t>5. Dynamic Follow-Up Questions: Presents 3 high-yield questions in Odia/Hindi for nurse to ask at bedside.</a:t>
             </a:r>
           </a:p>
         </p:txBody>
@@ -6906,7 +7029,7 @@
               </a:defRPr>
             </a:pPr>
             <a:r>
-              <a:t>Technical Architecture: Modern, Scalable &amp; Offline-Resilient</a:t>
+              <a:t>Odisha Public Health Network &amp; Official NHM Referral Engine</a:t>
             </a:r>
           </a:p>
         </p:txBody>
@@ -6963,7 +7086,7 @@
         <p:spPr>
           <a:xfrm>
             <a:off x="731520" y="1508760"/>
-            <a:ext cx="2560320" cy="4892040"/>
+            <a:ext cx="10728655" cy="1691640"/>
           </a:xfrm>
           <a:prstGeom prst="roundRect">
             <a:avLst/>
@@ -6971,9 +7094,9 @@
           <a:solidFill>
             <a:srgbClr val="131A2A"/>
           </a:solidFill>
-          <a:ln w="12700">
+          <a:ln>
             <a:solidFill>
-              <a:srgbClr val="27324B"/>
+              <a:srgbClr val="14B8A6"/>
             </a:solidFill>
           </a:ln>
         </p:spPr>
@@ -6996,72 +7119,78 @@
           <a:lstStyle/>
           <a:p>
             <a:pPr algn="ctr">
-              <a:defRPr sz="1200" b="1">
-                <a:solidFill>
-                  <a:srgbClr val="FFFFFF"/>
-                </a:solidFill>
-              </a:defRPr>
-            </a:pPr>
-            <a:r>
-              <a:t>🎨 Modern React Frontend</a:t>
+              <a:defRPr sz="1300" b="1">
+                <a:solidFill>
+                  <a:srgbClr val="38BDF8"/>
+                </a:solidFill>
+              </a:defRPr>
+            </a:pPr>
+            <a:r>
+              <a:t>🏛️ Complete 6-Tier All-India Facility Network (National Health Facility Registry / NIN Standard):</a:t>
             </a:r>
           </a:p>
           <a:p>
             <a:pPr>
               <a:spcBef>
-                <a:spcPts val="800"/>
+                <a:spcPts val="400"/>
               </a:spcBef>
-              <a:defRPr sz="950">
+              <a:defRPr sz="1000">
                 <a:solidFill>
                   <a:srgbClr val="F1F5F9"/>
                 </a:solidFill>
               </a:defRPr>
             </a:pPr>
             <a:r>
-              <a:t>• React 18, Vite, Tailwind CSS</a:t>
+              <a:t>• PHC Jatni, Khordha (OD-KHD-PHC-102) ➔ Rural First-Line Triage</a:t>
             </a:r>
             <a:br/>
             <a:r>
-              <a:t>• Lucide Medical Icons &amp; Bento Vitals</a:t>
+              <a:t>• CHC Tangi, Khordha (OD-KHD-CHC-204) ➔ Block-Level Community Health Center</a:t>
             </a:r>
             <a:br/>
             <a:r>
-              <a:t>• Web Speech API (or-IN, hi-IN, en-IN)</a:t>
+              <a:t>• Capital Hospital, Bhubaneswar (OD-DHH-401) ➔ 750-Bed District Headquarter Hospital</a:t>
             </a:r>
             <a:br/>
             <a:r>
-              <a:t>• SpeechSynthesis audio question playback</a:t>
+              <a:t>• SCB Medical College, Cuttack (OD-MCH-001) ➔ Apex Tertiary Emergency &amp; Trauma Bay</a:t>
             </a:r>
             <a:br/>
             <a:r>
-              <a:t>• Interactive 2D Anatomical Body Map</a:t>
+              <a:t>• Paradeep Industrial Unit (OD-JSP-IEH-301) ➔ Industrial Port Trust Occupational Screening</a:t>
             </a:r>
             <a:br/>
             <a:r>
-              <a:t>• Holographic ABHA verified card widget</a:t>
-            </a:r>
-          </a:p>
-        </p:txBody>
-      </p:sp>
-      <p:sp>
-        <p:nvSpPr>
-          <p:cNvPr id="8" name="Rectangle 7"/>
+              <a:t>• Koraput Mobile Health Camp (OD-KPT-MOBI-501) ➔ Tribal Health Mission Outreach</a:t>
+            </a:r>
+            <a:br/>
+            <a:r>
+              <a:t>• Flagship National Anchors: AIIMS New Delhi (DL-NDLS-AIIMS-001) &amp; Thane MIDC Maharashtra (MH-THN-MIDC-402)</a:t>
+            </a:r>
+          </a:p>
+        </p:txBody>
+      </p:sp>
+      <p:sp>
+        <p:nvSpPr>
+          <p:cNvPr id="8" name="Rounded Rectangle 7"/>
           <p:cNvSpPr/>
           <p:nvPr/>
         </p:nvSpPr>
         <p:spPr>
           <a:xfrm>
-            <a:off x="731520" y="1508760"/>
-            <a:ext cx="2560320" cy="73152"/>
-          </a:xfrm>
-          <a:prstGeom prst="rect">
-            <a:avLst/>
-          </a:prstGeom>
-          <a:solidFill>
-            <a:srgbClr val="14B8A6"/>
-          </a:solidFill>
-          <a:ln>
-            <a:noFill/>
+            <a:off x="731520" y="3383280"/>
+            <a:ext cx="10728655" cy="3017520"/>
+          </a:xfrm>
+          <a:prstGeom prst="roundRect">
+            <a:avLst/>
+          </a:prstGeom>
+          <a:solidFill>
+            <a:srgbClr val="1C121C"/>
+          </a:solidFill>
+          <a:ln w="19050">
+            <a:solidFill>
+              <a:srgbClr val="F43F5E"/>
+            </a:solidFill>
           </a:ln>
         </p:spPr>
         <p:style>
@@ -7079,394 +7208,62 @@
           </a:fontRef>
         </p:style>
         <p:txBody>
-          <a:bodyPr rtlCol="0" anchor="ctr"/>
-          <a:lstStyle/>
-          <a:p>
-            <a:pPr algn="ctr"/>
-          </a:p>
-        </p:txBody>
-      </p:sp>
-      <p:sp>
-        <p:nvSpPr>
-          <p:cNvPr id="9" name="Rounded Rectangle 8"/>
-          <p:cNvSpPr/>
-          <p:nvPr/>
-        </p:nvSpPr>
-        <p:spPr>
-          <a:xfrm>
-            <a:off x="3456432" y="1508760"/>
-            <a:ext cx="2560320" cy="4892040"/>
-          </a:xfrm>
-          <a:prstGeom prst="roundRect">
-            <a:avLst/>
-          </a:prstGeom>
-          <a:solidFill>
-            <a:srgbClr val="131A2A"/>
-          </a:solidFill>
-          <a:ln w="12700">
-            <a:solidFill>
-              <a:srgbClr val="27324B"/>
-            </a:solidFill>
-          </a:ln>
-        </p:spPr>
-        <p:style>
-          <a:lnRef idx="1">
-            <a:schemeClr val="accent1"/>
-          </a:lnRef>
-          <a:fillRef idx="3">
-            <a:schemeClr val="accent1"/>
-          </a:fillRef>
-          <a:effectRef idx="2">
-            <a:schemeClr val="accent1"/>
-          </a:effectRef>
-          <a:fontRef idx="minor">
-            <a:schemeClr val="lt1"/>
-          </a:fontRef>
-        </p:style>
-        <p:txBody>
           <a:bodyPr rtlCol="0" anchor="ctr" wrap="square"/>
           <a:lstStyle/>
           <a:p>
             <a:pPr algn="ctr">
               <a:defRPr sz="1200" b="1">
                 <a:solidFill>
-                  <a:srgbClr val="FFFFFF"/>
-                </a:solidFill>
-              </a:defRPr>
-            </a:pPr>
-            <a:r>
-              <a:t>⚡ FastAPI High-Speed Backend</a:t>
+                  <a:srgbClr val="F43F5E"/>
+                </a:solidFill>
+              </a:defRPr>
+            </a:pPr>
+            <a:r>
+              <a:t>📄 GOVERNMENT OF ODISHA • HEALTH &amp; FAMILY WELFARE DEPARTMENT — NHM CLINICAL REFERRAL SLIP</a:t>
             </a:r>
           </a:p>
           <a:p>
             <a:pPr>
               <a:spcBef>
-                <a:spcPts val="800"/>
+                <a:spcPts val="600"/>
               </a:spcBef>
-              <a:defRPr sz="950">
+              <a:defRPr sz="1000">
                 <a:solidFill>
                   <a:srgbClr val="F1F5F9"/>
                 </a:solidFill>
               </a:defRPr>
             </a:pPr>
             <a:r>
-              <a:t>• Python 3.11+ with async FastAPI</a:t>
+              <a:t>Referring Facility: Primary Health Center (PHC) Jatni, Khordha (NIN: OD-KHD-PHC-102)</a:t>
             </a:r>
             <a:br/>
             <a:r>
-              <a:t>• Strict Pydantic v2 schemas (all 10 domains)</a:t>
+              <a:t>Referred To: Emergency Resuscitation Bay, Capital Hospital Bhubaneswar / SCB Medical College, Cuttack</a:t>
             </a:r>
             <a:br/>
             <a:r>
-              <a:t>• Interactive OpenAPI 3.1 Swagger Docs (/docs)</a:t>
+              <a:t>Patient: Ramesh K. | ABHA ID: 91-4821-9923-0192 | Token: T-024 | Age/Sex: 62y/Male</a:t>
             </a:r>
             <a:br/>
             <a:r>
-              <a:t>• In-memory clinical queue with persistence</a:t>
+              <a:t>Chief Complaint: Retrosternal crushing chest pain &amp; severe dyspnea (2 hours duration)</a:t>
             </a:r>
             <a:br/>
             <a:r>
-              <a:t>• Zero-delay response (&lt;50ms deterministic scoring)</a:t>
-            </a:r>
-          </a:p>
-        </p:txBody>
-      </p:sp>
-      <p:sp>
-        <p:nvSpPr>
-          <p:cNvPr id="10" name="Rectangle 9"/>
-          <p:cNvSpPr/>
-          <p:nvPr/>
-        </p:nvSpPr>
-        <p:spPr>
-          <a:xfrm>
-            <a:off x="3456432" y="1508760"/>
-            <a:ext cx="2560320" cy="73152"/>
-          </a:xfrm>
-          <a:prstGeom prst="rect">
-            <a:avLst/>
-          </a:prstGeom>
-          <a:solidFill>
-            <a:srgbClr val="14B8A6"/>
-          </a:solidFill>
-          <a:ln>
-            <a:noFill/>
-          </a:ln>
-        </p:spPr>
-        <p:style>
-          <a:lnRef idx="1">
-            <a:schemeClr val="accent1"/>
-          </a:lnRef>
-          <a:fillRef idx="3">
-            <a:schemeClr val="accent1"/>
-          </a:fillRef>
-          <a:effectRef idx="2">
-            <a:schemeClr val="accent1"/>
-          </a:effectRef>
-          <a:fontRef idx="minor">
-            <a:schemeClr val="lt1"/>
-          </a:fontRef>
-        </p:style>
-        <p:txBody>
-          <a:bodyPr rtlCol="0" anchor="ctr"/>
-          <a:lstStyle/>
-          <a:p>
-            <a:pPr algn="ctr"/>
-          </a:p>
-        </p:txBody>
-      </p:sp>
-      <p:sp>
-        <p:nvSpPr>
-          <p:cNvPr id="11" name="Rounded Rectangle 10"/>
-          <p:cNvSpPr/>
-          <p:nvPr/>
-        </p:nvSpPr>
-        <p:spPr>
-          <a:xfrm>
-            <a:off x="6181344" y="1508760"/>
-            <a:ext cx="2560320" cy="4892040"/>
-          </a:xfrm>
-          <a:prstGeom prst="roundRect">
-            <a:avLst/>
-          </a:prstGeom>
-          <a:solidFill>
-            <a:srgbClr val="131A2A"/>
-          </a:solidFill>
-          <a:ln w="12700">
-            <a:solidFill>
-              <a:srgbClr val="27324B"/>
-            </a:solidFill>
-          </a:ln>
-        </p:spPr>
-        <p:style>
-          <a:lnRef idx="1">
-            <a:schemeClr val="accent1"/>
-          </a:lnRef>
-          <a:fillRef idx="3">
-            <a:schemeClr val="accent1"/>
-          </a:fillRef>
-          <a:effectRef idx="2">
-            <a:schemeClr val="accent1"/>
-          </a:effectRef>
-          <a:fontRef idx="minor">
-            <a:schemeClr val="lt1"/>
-          </a:fontRef>
-        </p:style>
-        <p:txBody>
-          <a:bodyPr rtlCol="0" anchor="ctr" wrap="square"/>
-          <a:lstStyle/>
-          <a:p>
-            <a:pPr algn="ctr">
-              <a:defRPr sz="1200" b="1">
-                <a:solidFill>
-                  <a:srgbClr val="FFFFFF"/>
-                </a:solidFill>
-              </a:defRPr>
-            </a:pPr>
-            <a:r>
-              <a:t>🧠 Gemini 2.5 Flash Multimodal AI</a:t>
-            </a:r>
-          </a:p>
-          <a:p>
-            <a:pPr>
-              <a:spcBef>
-                <a:spcPts val="800"/>
-              </a:spcBef>
-              <a:defRPr sz="950">
-                <a:solidFill>
-                  <a:srgbClr val="F1F5F9"/>
-                </a:solidFill>
-              </a:defRPr>
-            </a:pPr>
-            <a:r>
-              <a:t>• Official google-genai Python SDK</a:t>
+              <a:t>Triage Classification: 🔴 RED PRIORITY (Immediate Medical Officer Assessment Required)</a:t>
             </a:r>
             <a:br/>
             <a:r>
-              <a:t>• Native audio, text, and report OCR in 1 call</a:t>
+              <a:t>Departure Vitals: SpO₂ 89% (Room Air), BP 158/96 mmHg, Pulse 112 bpm, RR 26/min, Temp 99.8°F</a:t>
             </a:r>
             <a:br/>
             <a:r>
-              <a:t>• Enforces strict Pydantic JSON response_schema</a:t>
+              <a:t>Pre-Referral Stabilization: Oxygen initiated via nasal cannula at 4 L/min. Aspirin 300mg stat administered.</a:t>
             </a:r>
             <a:br/>
             <a:r>
-              <a:t>• Intelligent local fallback mode when offline</a:t>
-            </a:r>
-            <a:br/>
-            <a:r>
-              <a:t>• Culturally empathetic Odia &amp; Hindi prompts</a:t>
-            </a:r>
-          </a:p>
-        </p:txBody>
-      </p:sp>
-      <p:sp>
-        <p:nvSpPr>
-          <p:cNvPr id="12" name="Rectangle 11"/>
-          <p:cNvSpPr/>
-          <p:nvPr/>
-        </p:nvSpPr>
-        <p:spPr>
-          <a:xfrm>
-            <a:off x="6181344" y="1508760"/>
-            <a:ext cx="2560320" cy="73152"/>
-          </a:xfrm>
-          <a:prstGeom prst="rect">
-            <a:avLst/>
-          </a:prstGeom>
-          <a:solidFill>
-            <a:srgbClr val="14B8A6"/>
-          </a:solidFill>
-          <a:ln>
-            <a:noFill/>
-          </a:ln>
-        </p:spPr>
-        <p:style>
-          <a:lnRef idx="1">
-            <a:schemeClr val="accent1"/>
-          </a:lnRef>
-          <a:fillRef idx="3">
-            <a:schemeClr val="accent1"/>
-          </a:fillRef>
-          <a:effectRef idx="2">
-            <a:schemeClr val="accent1"/>
-          </a:effectRef>
-          <a:fontRef idx="minor">
-            <a:schemeClr val="lt1"/>
-          </a:fontRef>
-        </p:style>
-        <p:txBody>
-          <a:bodyPr rtlCol="0" anchor="ctr"/>
-          <a:lstStyle/>
-          <a:p>
-            <a:pPr algn="ctr"/>
-          </a:p>
-        </p:txBody>
-      </p:sp>
-      <p:sp>
-        <p:nvSpPr>
-          <p:cNvPr id="13" name="Rounded Rectangle 12"/>
-          <p:cNvSpPr/>
-          <p:nvPr/>
-        </p:nvSpPr>
-        <p:spPr>
-          <a:xfrm>
-            <a:off x="8906256" y="1508760"/>
-            <a:ext cx="2560320" cy="4892040"/>
-          </a:xfrm>
-          <a:prstGeom prst="roundRect">
-            <a:avLst/>
-          </a:prstGeom>
-          <a:solidFill>
-            <a:srgbClr val="131A2A"/>
-          </a:solidFill>
-          <a:ln w="12700">
-            <a:solidFill>
-              <a:srgbClr val="27324B"/>
-            </a:solidFill>
-          </a:ln>
-        </p:spPr>
-        <p:style>
-          <a:lnRef idx="1">
-            <a:schemeClr val="accent1"/>
-          </a:lnRef>
-          <a:fillRef idx="3">
-            <a:schemeClr val="accent1"/>
-          </a:fillRef>
-          <a:effectRef idx="2">
-            <a:schemeClr val="accent1"/>
-          </a:effectRef>
-          <a:fontRef idx="minor">
-            <a:schemeClr val="lt1"/>
-          </a:fontRef>
-        </p:style>
-        <p:txBody>
-          <a:bodyPr rtlCol="0" anchor="ctr" wrap="square"/>
-          <a:lstStyle/>
-          <a:p>
-            <a:pPr algn="ctr">
-              <a:defRPr sz="1200" b="1">
-                <a:solidFill>
-                  <a:srgbClr val="FFFFFF"/>
-                </a:solidFill>
-              </a:defRPr>
-            </a:pPr>
-            <a:r>
-              <a:t>📶 Offline-First PWA Resilience</a:t>
-            </a:r>
-          </a:p>
-          <a:p>
-            <a:pPr>
-              <a:spcBef>
-                <a:spcPts val="800"/>
-              </a:spcBef>
-              <a:defRPr sz="950">
-                <a:solidFill>
-                  <a:srgbClr val="F1F5F9"/>
-                </a:solidFill>
-              </a:defRPr>
-            </a:pPr>
-            <a:r>
-              <a:t>• IndexedDB / LocalStorage queue buffer</a:t>
-            </a:r>
-            <a:br/>
-            <a:r>
-              <a:t>• Client-side mirror deterministic rule engine</a:t>
-            </a:r>
-            <a:br/>
-            <a:r>
-              <a:t>• If rural PHC internet cuts out, triage never stops</a:t>
-            </a:r>
-            <a:br/>
-            <a:r>
-              <a:t>• Auto-syncs queued patients when back online</a:t>
-            </a:r>
-            <a:br/>
-            <a:r>
-              <a:t>• 100% demo safety on hackathon stage</a:t>
-            </a:r>
-          </a:p>
-        </p:txBody>
-      </p:sp>
-      <p:sp>
-        <p:nvSpPr>
-          <p:cNvPr id="14" name="Rectangle 13"/>
-          <p:cNvSpPr/>
-          <p:nvPr/>
-        </p:nvSpPr>
-        <p:spPr>
-          <a:xfrm>
-            <a:off x="8906256" y="1508760"/>
-            <a:ext cx="2560320" cy="73152"/>
-          </a:xfrm>
-          <a:prstGeom prst="rect">
-            <a:avLst/>
-          </a:prstGeom>
-          <a:solidFill>
-            <a:srgbClr val="14B8A6"/>
-          </a:solidFill>
-          <a:ln>
-            <a:noFill/>
-          </a:ln>
-        </p:spPr>
-        <p:style>
-          <a:lnRef idx="1">
-            <a:schemeClr val="accent1"/>
-          </a:lnRef>
-          <a:fillRef idx="3">
-            <a:schemeClr val="accent1"/>
-          </a:fillRef>
-          <a:effectRef idx="2">
-            <a:schemeClr val="accent1"/>
-          </a:effectRef>
-          <a:fontRef idx="minor">
-            <a:schemeClr val="lt1"/>
-          </a:fontRef>
-        </p:style>
-        <p:txBody>
-          <a:bodyPr rtlCol="0" anchor="ctr"/>
-          <a:lstStyle/>
-          <a:p>
-            <a:pPr algn="ctr"/>
+              <a:t>Escort Logistics: 108 Emergency Ambulance Dispatched • Emergency Transfer Barcode Generated for Zero-Wait Reception</a:t>
+            </a:r>
           </a:p>
         </p:txBody>
       </p:sp>
@@ -7479,6 +7276,760 @@
 </file>
 
 <file path=ppt/slides/slide8.xml><?xml version="1.0" encoding="utf-8"?>
+<p:sld xmlns:a="http://schemas.openxmlformats.org/drawingml/2006/main" xmlns:p="http://schemas.openxmlformats.org/presentationml/2006/main" xmlns:r="http://schemas.openxmlformats.org/officeDocument/2006/relationships">
+  <p:cSld>
+    <p:spTree>
+      <p:nvGrpSpPr>
+        <p:cNvPr id="1" name=""/>
+        <p:cNvGrpSpPr/>
+        <p:nvPr/>
+      </p:nvGrpSpPr>
+      <p:grpSpPr/>
+      <p:sp>
+        <p:nvSpPr>
+          <p:cNvPr id="2" name="Rectangle 1"/>
+          <p:cNvSpPr/>
+          <p:nvPr/>
+        </p:nvSpPr>
+        <p:spPr>
+          <a:xfrm>
+            <a:off x="0" y="0"/>
+            <a:ext cx="12191695" cy="6858000"/>
+          </a:xfrm>
+          <a:prstGeom prst="rect">
+            <a:avLst/>
+          </a:prstGeom>
+          <a:solidFill>
+            <a:srgbClr val="0B0F19"/>
+          </a:solidFill>
+          <a:ln>
+            <a:noFill/>
+          </a:ln>
+        </p:spPr>
+        <p:style>
+          <a:lnRef idx="1">
+            <a:schemeClr val="accent1"/>
+          </a:lnRef>
+          <a:fillRef idx="3">
+            <a:schemeClr val="accent1"/>
+          </a:fillRef>
+          <a:effectRef idx="2">
+            <a:schemeClr val="accent1"/>
+          </a:effectRef>
+          <a:fontRef idx="minor">
+            <a:schemeClr val="lt1"/>
+          </a:fontRef>
+        </p:style>
+        <p:txBody>
+          <a:bodyPr rtlCol="0" anchor="ctr"/>
+          <a:lstStyle/>
+          <a:p>
+            <a:pPr algn="ctr"/>
+          </a:p>
+        </p:txBody>
+      </p:sp>
+      <p:sp>
+        <p:nvSpPr>
+          <p:cNvPr id="3" name="Rectangle 2"/>
+          <p:cNvSpPr/>
+          <p:nvPr/>
+        </p:nvSpPr>
+        <p:spPr>
+          <a:xfrm>
+            <a:off x="0" y="0"/>
+            <a:ext cx="12191695" cy="73152"/>
+          </a:xfrm>
+          <a:prstGeom prst="rect">
+            <a:avLst/>
+          </a:prstGeom>
+          <a:solidFill>
+            <a:srgbClr val="14B8A6"/>
+          </a:solidFill>
+          <a:ln>
+            <a:noFill/>
+          </a:ln>
+        </p:spPr>
+        <p:style>
+          <a:lnRef idx="1">
+            <a:schemeClr val="accent1"/>
+          </a:lnRef>
+          <a:fillRef idx="3">
+            <a:schemeClr val="accent1"/>
+          </a:fillRef>
+          <a:effectRef idx="2">
+            <a:schemeClr val="accent1"/>
+          </a:effectRef>
+          <a:fontRef idx="minor">
+            <a:schemeClr val="lt1"/>
+          </a:fontRef>
+        </p:style>
+        <p:txBody>
+          <a:bodyPr rtlCol="0" anchor="ctr"/>
+          <a:lstStyle/>
+          <a:p>
+            <a:pPr algn="ctr"/>
+          </a:p>
+        </p:txBody>
+      </p:sp>
+      <p:sp>
+        <p:nvSpPr>
+          <p:cNvPr id="4" name="Rounded Rectangle 3"/>
+          <p:cNvSpPr/>
+          <p:nvPr/>
+        </p:nvSpPr>
+        <p:spPr>
+          <a:xfrm>
+            <a:off x="731520" y="320040"/>
+            <a:ext cx="4114800" cy="320040"/>
+          </a:xfrm>
+          <a:prstGeom prst="roundRect">
+            <a:avLst/>
+          </a:prstGeom>
+          <a:solidFill>
+            <a:srgbClr val="111E30"/>
+          </a:solidFill>
+          <a:ln w="12700">
+            <a:solidFill>
+              <a:srgbClr val="0D9488"/>
+            </a:solidFill>
+          </a:ln>
+        </p:spPr>
+        <p:style>
+          <a:lnRef idx="1">
+            <a:schemeClr val="accent1"/>
+          </a:lnRef>
+          <a:fillRef idx="3">
+            <a:schemeClr val="accent1"/>
+          </a:fillRef>
+          <a:effectRef idx="2">
+            <a:schemeClr val="accent1"/>
+          </a:effectRef>
+          <a:fontRef idx="minor">
+            <a:schemeClr val="lt1"/>
+          </a:fontRef>
+        </p:style>
+        <p:txBody>
+          <a:bodyPr rtlCol="0" anchor="ctr"/>
+          <a:lstStyle/>
+          <a:p>
+            <a:pPr algn="ctr">
+              <a:defRPr sz="950" b="1">
+                <a:solidFill>
+                  <a:srgbClr val="38BDF8"/>
+                </a:solidFill>
+                <a:latin typeface="Arial"/>
+              </a:defRPr>
+            </a:pPr>
+            <a:r>
+              <a:t>BPUT HACKATHON 2026 • AI HEALTHCARE TRACK</a:t>
+            </a:r>
+          </a:p>
+        </p:txBody>
+      </p:sp>
+      <p:sp>
+        <p:nvSpPr>
+          <p:cNvPr id="5" name="TextBox 4"/>
+          <p:cNvSpPr txBox="1"/>
+          <p:nvPr/>
+        </p:nvSpPr>
+        <p:spPr>
+          <a:xfrm>
+            <a:off x="731520" y="658368"/>
+            <a:ext cx="10698480" cy="594360"/>
+          </a:xfrm>
+          <a:prstGeom prst="rect">
+            <a:avLst/>
+          </a:prstGeom>
+          <a:noFill/>
+        </p:spPr>
+        <p:txBody>
+          <a:bodyPr wrap="square">
+            <a:spAutoFit/>
+          </a:bodyPr>
+          <a:lstStyle/>
+          <a:p>
+            <a:pPr>
+              <a:defRPr sz="2300" b="1">
+                <a:solidFill>
+                  <a:srgbClr val="FFFFFF"/>
+                </a:solidFill>
+                <a:latin typeface="Arial"/>
+              </a:defRPr>
+            </a:pPr>
+            <a:r>
+              <a:t>Technical Architecture: Modern, Scalable &amp; Offline-Resilient</a:t>
+            </a:r>
+          </a:p>
+        </p:txBody>
+      </p:sp>
+      <p:sp>
+        <p:nvSpPr>
+          <p:cNvPr id="6" name="Rectangle 5"/>
+          <p:cNvSpPr/>
+          <p:nvPr/>
+        </p:nvSpPr>
+        <p:spPr>
+          <a:xfrm>
+            <a:off x="731520" y="1280160"/>
+            <a:ext cx="10728655" cy="13716"/>
+          </a:xfrm>
+          <a:prstGeom prst="rect">
+            <a:avLst/>
+          </a:prstGeom>
+          <a:solidFill>
+            <a:srgbClr val="27324B"/>
+          </a:solidFill>
+          <a:ln>
+            <a:noFill/>
+          </a:ln>
+        </p:spPr>
+        <p:style>
+          <a:lnRef idx="1">
+            <a:schemeClr val="accent1"/>
+          </a:lnRef>
+          <a:fillRef idx="3">
+            <a:schemeClr val="accent1"/>
+          </a:fillRef>
+          <a:effectRef idx="2">
+            <a:schemeClr val="accent1"/>
+          </a:effectRef>
+          <a:fontRef idx="minor">
+            <a:schemeClr val="lt1"/>
+          </a:fontRef>
+        </p:style>
+        <p:txBody>
+          <a:bodyPr rtlCol="0" anchor="ctr"/>
+          <a:lstStyle/>
+          <a:p>
+            <a:pPr algn="ctr"/>
+          </a:p>
+        </p:txBody>
+      </p:sp>
+      <p:sp>
+        <p:nvSpPr>
+          <p:cNvPr id="7" name="Rounded Rectangle 6"/>
+          <p:cNvSpPr/>
+          <p:nvPr/>
+        </p:nvSpPr>
+        <p:spPr>
+          <a:xfrm>
+            <a:off x="731520" y="1508760"/>
+            <a:ext cx="2560320" cy="4892040"/>
+          </a:xfrm>
+          <a:prstGeom prst="roundRect">
+            <a:avLst/>
+          </a:prstGeom>
+          <a:solidFill>
+            <a:srgbClr val="131A2A"/>
+          </a:solidFill>
+          <a:ln w="12700">
+            <a:solidFill>
+              <a:srgbClr val="27324B"/>
+            </a:solidFill>
+          </a:ln>
+        </p:spPr>
+        <p:style>
+          <a:lnRef idx="1">
+            <a:schemeClr val="accent1"/>
+          </a:lnRef>
+          <a:fillRef idx="3">
+            <a:schemeClr val="accent1"/>
+          </a:fillRef>
+          <a:effectRef idx="2">
+            <a:schemeClr val="accent1"/>
+          </a:effectRef>
+          <a:fontRef idx="minor">
+            <a:schemeClr val="lt1"/>
+          </a:fontRef>
+        </p:style>
+        <p:txBody>
+          <a:bodyPr rtlCol="0" anchor="ctr" wrap="square"/>
+          <a:lstStyle/>
+          <a:p>
+            <a:pPr algn="ctr">
+              <a:defRPr sz="1200" b="1">
+                <a:solidFill>
+                  <a:srgbClr val="FFFFFF"/>
+                </a:solidFill>
+              </a:defRPr>
+            </a:pPr>
+            <a:r>
+              <a:t>🎨 Modern React Frontend</a:t>
+            </a:r>
+          </a:p>
+          <a:p>
+            <a:pPr>
+              <a:spcBef>
+                <a:spcPts val="800"/>
+              </a:spcBef>
+              <a:defRPr sz="950">
+                <a:solidFill>
+                  <a:srgbClr val="F1F5F9"/>
+                </a:solidFill>
+              </a:defRPr>
+            </a:pPr>
+            <a:r>
+              <a:t>• React 18, Vite, Tailwind CSS</a:t>
+            </a:r>
+            <a:br/>
+            <a:r>
+              <a:t>• Lucide Medical Icons &amp; Bento Vitals</a:t>
+            </a:r>
+            <a:br/>
+            <a:r>
+              <a:t>• Web Speech API (or-IN, hi-IN, en-IN)</a:t>
+            </a:r>
+            <a:br/>
+            <a:r>
+              <a:t>• SpeechSynthesis audio question playback</a:t>
+            </a:r>
+            <a:br/>
+            <a:r>
+              <a:t>• Interactive 2D Anatomical Body Map</a:t>
+            </a:r>
+            <a:br/>
+            <a:r>
+              <a:t>• Holographic ABHA verified card widget</a:t>
+            </a:r>
+          </a:p>
+        </p:txBody>
+      </p:sp>
+      <p:sp>
+        <p:nvSpPr>
+          <p:cNvPr id="8" name="Rectangle 7"/>
+          <p:cNvSpPr/>
+          <p:nvPr/>
+        </p:nvSpPr>
+        <p:spPr>
+          <a:xfrm>
+            <a:off x="731520" y="1508760"/>
+            <a:ext cx="2560320" cy="73152"/>
+          </a:xfrm>
+          <a:prstGeom prst="rect">
+            <a:avLst/>
+          </a:prstGeom>
+          <a:solidFill>
+            <a:srgbClr val="14B8A6"/>
+          </a:solidFill>
+          <a:ln>
+            <a:noFill/>
+          </a:ln>
+        </p:spPr>
+        <p:style>
+          <a:lnRef idx="1">
+            <a:schemeClr val="accent1"/>
+          </a:lnRef>
+          <a:fillRef idx="3">
+            <a:schemeClr val="accent1"/>
+          </a:fillRef>
+          <a:effectRef idx="2">
+            <a:schemeClr val="accent1"/>
+          </a:effectRef>
+          <a:fontRef idx="minor">
+            <a:schemeClr val="lt1"/>
+          </a:fontRef>
+        </p:style>
+        <p:txBody>
+          <a:bodyPr rtlCol="0" anchor="ctr"/>
+          <a:lstStyle/>
+          <a:p>
+            <a:pPr algn="ctr"/>
+          </a:p>
+        </p:txBody>
+      </p:sp>
+      <p:sp>
+        <p:nvSpPr>
+          <p:cNvPr id="9" name="Rounded Rectangle 8"/>
+          <p:cNvSpPr/>
+          <p:nvPr/>
+        </p:nvSpPr>
+        <p:spPr>
+          <a:xfrm>
+            <a:off x="3456432" y="1508760"/>
+            <a:ext cx="2560320" cy="4892040"/>
+          </a:xfrm>
+          <a:prstGeom prst="roundRect">
+            <a:avLst/>
+          </a:prstGeom>
+          <a:solidFill>
+            <a:srgbClr val="131A2A"/>
+          </a:solidFill>
+          <a:ln w="12700">
+            <a:solidFill>
+              <a:srgbClr val="27324B"/>
+            </a:solidFill>
+          </a:ln>
+        </p:spPr>
+        <p:style>
+          <a:lnRef idx="1">
+            <a:schemeClr val="accent1"/>
+          </a:lnRef>
+          <a:fillRef idx="3">
+            <a:schemeClr val="accent1"/>
+          </a:fillRef>
+          <a:effectRef idx="2">
+            <a:schemeClr val="accent1"/>
+          </a:effectRef>
+          <a:fontRef idx="minor">
+            <a:schemeClr val="lt1"/>
+          </a:fontRef>
+        </p:style>
+        <p:txBody>
+          <a:bodyPr rtlCol="0" anchor="ctr" wrap="square"/>
+          <a:lstStyle/>
+          <a:p>
+            <a:pPr algn="ctr">
+              <a:defRPr sz="1200" b="1">
+                <a:solidFill>
+                  <a:srgbClr val="FFFFFF"/>
+                </a:solidFill>
+              </a:defRPr>
+            </a:pPr>
+            <a:r>
+              <a:t>⚡ FastAPI High-Speed Backend</a:t>
+            </a:r>
+          </a:p>
+          <a:p>
+            <a:pPr>
+              <a:spcBef>
+                <a:spcPts val="800"/>
+              </a:spcBef>
+              <a:defRPr sz="950">
+                <a:solidFill>
+                  <a:srgbClr val="F1F5F9"/>
+                </a:solidFill>
+              </a:defRPr>
+            </a:pPr>
+            <a:r>
+              <a:t>• Python 3.11+ with async FastAPI</a:t>
+            </a:r>
+            <a:br/>
+            <a:r>
+              <a:t>• Strict Pydantic v2 schemas (all 10 domains)</a:t>
+            </a:r>
+            <a:br/>
+            <a:r>
+              <a:t>• Interactive OpenAPI 3.1 Swagger Docs (/docs)</a:t>
+            </a:r>
+            <a:br/>
+            <a:r>
+              <a:t>• In-memory clinical queue with persistence</a:t>
+            </a:r>
+            <a:br/>
+            <a:r>
+              <a:t>• Zero-delay response (&lt;50ms deterministic scoring)</a:t>
+            </a:r>
+          </a:p>
+        </p:txBody>
+      </p:sp>
+      <p:sp>
+        <p:nvSpPr>
+          <p:cNvPr id="10" name="Rectangle 9"/>
+          <p:cNvSpPr/>
+          <p:nvPr/>
+        </p:nvSpPr>
+        <p:spPr>
+          <a:xfrm>
+            <a:off x="3456432" y="1508760"/>
+            <a:ext cx="2560320" cy="73152"/>
+          </a:xfrm>
+          <a:prstGeom prst="rect">
+            <a:avLst/>
+          </a:prstGeom>
+          <a:solidFill>
+            <a:srgbClr val="14B8A6"/>
+          </a:solidFill>
+          <a:ln>
+            <a:noFill/>
+          </a:ln>
+        </p:spPr>
+        <p:style>
+          <a:lnRef idx="1">
+            <a:schemeClr val="accent1"/>
+          </a:lnRef>
+          <a:fillRef idx="3">
+            <a:schemeClr val="accent1"/>
+          </a:fillRef>
+          <a:effectRef idx="2">
+            <a:schemeClr val="accent1"/>
+          </a:effectRef>
+          <a:fontRef idx="minor">
+            <a:schemeClr val="lt1"/>
+          </a:fontRef>
+        </p:style>
+        <p:txBody>
+          <a:bodyPr rtlCol="0" anchor="ctr"/>
+          <a:lstStyle/>
+          <a:p>
+            <a:pPr algn="ctr"/>
+          </a:p>
+        </p:txBody>
+      </p:sp>
+      <p:sp>
+        <p:nvSpPr>
+          <p:cNvPr id="11" name="Rounded Rectangle 10"/>
+          <p:cNvSpPr/>
+          <p:nvPr/>
+        </p:nvSpPr>
+        <p:spPr>
+          <a:xfrm>
+            <a:off x="6181344" y="1508760"/>
+            <a:ext cx="2560320" cy="4892040"/>
+          </a:xfrm>
+          <a:prstGeom prst="roundRect">
+            <a:avLst/>
+          </a:prstGeom>
+          <a:solidFill>
+            <a:srgbClr val="131A2A"/>
+          </a:solidFill>
+          <a:ln w="12700">
+            <a:solidFill>
+              <a:srgbClr val="27324B"/>
+            </a:solidFill>
+          </a:ln>
+        </p:spPr>
+        <p:style>
+          <a:lnRef idx="1">
+            <a:schemeClr val="accent1"/>
+          </a:lnRef>
+          <a:fillRef idx="3">
+            <a:schemeClr val="accent1"/>
+          </a:fillRef>
+          <a:effectRef idx="2">
+            <a:schemeClr val="accent1"/>
+          </a:effectRef>
+          <a:fontRef idx="minor">
+            <a:schemeClr val="lt1"/>
+          </a:fontRef>
+        </p:style>
+        <p:txBody>
+          <a:bodyPr rtlCol="0" anchor="ctr" wrap="square"/>
+          <a:lstStyle/>
+          <a:p>
+            <a:pPr algn="ctr">
+              <a:defRPr sz="1200" b="1">
+                <a:solidFill>
+                  <a:srgbClr val="FFFFFF"/>
+                </a:solidFill>
+              </a:defRPr>
+            </a:pPr>
+            <a:r>
+              <a:t>🧠 Gemini 2.5 Flash Multimodal AI</a:t>
+            </a:r>
+          </a:p>
+          <a:p>
+            <a:pPr>
+              <a:spcBef>
+                <a:spcPts val="800"/>
+              </a:spcBef>
+              <a:defRPr sz="950">
+                <a:solidFill>
+                  <a:srgbClr val="F1F5F9"/>
+                </a:solidFill>
+              </a:defRPr>
+            </a:pPr>
+            <a:r>
+              <a:t>• Official google-genai Python SDK</a:t>
+            </a:r>
+            <a:br/>
+            <a:r>
+              <a:t>• Native audio, text, and report OCR in 1 call</a:t>
+            </a:r>
+            <a:br/>
+            <a:r>
+              <a:t>• Enforces strict Pydantic JSON response_schema</a:t>
+            </a:r>
+            <a:br/>
+            <a:r>
+              <a:t>• Intelligent local fallback mode when offline</a:t>
+            </a:r>
+            <a:br/>
+            <a:r>
+              <a:t>• Culturally empathetic Odia &amp; Hindi prompts</a:t>
+            </a:r>
+          </a:p>
+        </p:txBody>
+      </p:sp>
+      <p:sp>
+        <p:nvSpPr>
+          <p:cNvPr id="12" name="Rectangle 11"/>
+          <p:cNvSpPr/>
+          <p:nvPr/>
+        </p:nvSpPr>
+        <p:spPr>
+          <a:xfrm>
+            <a:off x="6181344" y="1508760"/>
+            <a:ext cx="2560320" cy="73152"/>
+          </a:xfrm>
+          <a:prstGeom prst="rect">
+            <a:avLst/>
+          </a:prstGeom>
+          <a:solidFill>
+            <a:srgbClr val="14B8A6"/>
+          </a:solidFill>
+          <a:ln>
+            <a:noFill/>
+          </a:ln>
+        </p:spPr>
+        <p:style>
+          <a:lnRef idx="1">
+            <a:schemeClr val="accent1"/>
+          </a:lnRef>
+          <a:fillRef idx="3">
+            <a:schemeClr val="accent1"/>
+          </a:fillRef>
+          <a:effectRef idx="2">
+            <a:schemeClr val="accent1"/>
+          </a:effectRef>
+          <a:fontRef idx="minor">
+            <a:schemeClr val="lt1"/>
+          </a:fontRef>
+        </p:style>
+        <p:txBody>
+          <a:bodyPr rtlCol="0" anchor="ctr"/>
+          <a:lstStyle/>
+          <a:p>
+            <a:pPr algn="ctr"/>
+          </a:p>
+        </p:txBody>
+      </p:sp>
+      <p:sp>
+        <p:nvSpPr>
+          <p:cNvPr id="13" name="Rounded Rectangle 12"/>
+          <p:cNvSpPr/>
+          <p:nvPr/>
+        </p:nvSpPr>
+        <p:spPr>
+          <a:xfrm>
+            <a:off x="8906256" y="1508760"/>
+            <a:ext cx="2560320" cy="4892040"/>
+          </a:xfrm>
+          <a:prstGeom prst="roundRect">
+            <a:avLst/>
+          </a:prstGeom>
+          <a:solidFill>
+            <a:srgbClr val="131A2A"/>
+          </a:solidFill>
+          <a:ln w="12700">
+            <a:solidFill>
+              <a:srgbClr val="27324B"/>
+            </a:solidFill>
+          </a:ln>
+        </p:spPr>
+        <p:style>
+          <a:lnRef idx="1">
+            <a:schemeClr val="accent1"/>
+          </a:lnRef>
+          <a:fillRef idx="3">
+            <a:schemeClr val="accent1"/>
+          </a:fillRef>
+          <a:effectRef idx="2">
+            <a:schemeClr val="accent1"/>
+          </a:effectRef>
+          <a:fontRef idx="minor">
+            <a:schemeClr val="lt1"/>
+          </a:fontRef>
+        </p:style>
+        <p:txBody>
+          <a:bodyPr rtlCol="0" anchor="ctr" wrap="square"/>
+          <a:lstStyle/>
+          <a:p>
+            <a:pPr algn="ctr">
+              <a:defRPr sz="1200" b="1">
+                <a:solidFill>
+                  <a:srgbClr val="FFFFFF"/>
+                </a:solidFill>
+              </a:defRPr>
+            </a:pPr>
+            <a:r>
+              <a:t>📶 Offline-First PWA Resilience</a:t>
+            </a:r>
+          </a:p>
+          <a:p>
+            <a:pPr>
+              <a:spcBef>
+                <a:spcPts val="800"/>
+              </a:spcBef>
+              <a:defRPr sz="950">
+                <a:solidFill>
+                  <a:srgbClr val="F1F5F9"/>
+                </a:solidFill>
+              </a:defRPr>
+            </a:pPr>
+            <a:r>
+              <a:t>• IndexedDB / LocalStorage queue buffer</a:t>
+            </a:r>
+            <a:br/>
+            <a:r>
+              <a:t>• Client-side mirror deterministic rule engine</a:t>
+            </a:r>
+            <a:br/>
+            <a:r>
+              <a:t>• If rural PHC internet cuts out, triage never stops</a:t>
+            </a:r>
+            <a:br/>
+            <a:r>
+              <a:t>• Auto-syncs queued patients when back online</a:t>
+            </a:r>
+            <a:br/>
+            <a:r>
+              <a:t>• 100% demo safety on hackathon stage</a:t>
+            </a:r>
+          </a:p>
+        </p:txBody>
+      </p:sp>
+      <p:sp>
+        <p:nvSpPr>
+          <p:cNvPr id="14" name="Rectangle 13"/>
+          <p:cNvSpPr/>
+          <p:nvPr/>
+        </p:nvSpPr>
+        <p:spPr>
+          <a:xfrm>
+            <a:off x="8906256" y="1508760"/>
+            <a:ext cx="2560320" cy="73152"/>
+          </a:xfrm>
+          <a:prstGeom prst="rect">
+            <a:avLst/>
+          </a:prstGeom>
+          <a:solidFill>
+            <a:srgbClr val="14B8A6"/>
+          </a:solidFill>
+          <a:ln>
+            <a:noFill/>
+          </a:ln>
+        </p:spPr>
+        <p:style>
+          <a:lnRef idx="1">
+            <a:schemeClr val="accent1"/>
+          </a:lnRef>
+          <a:fillRef idx="3">
+            <a:schemeClr val="accent1"/>
+          </a:fillRef>
+          <a:effectRef idx="2">
+            <a:schemeClr val="accent1"/>
+          </a:effectRef>
+          <a:fontRef idx="minor">
+            <a:schemeClr val="lt1"/>
+          </a:fontRef>
+        </p:style>
+        <p:txBody>
+          <a:bodyPr rtlCol="0" anchor="ctr"/>
+          <a:lstStyle/>
+          <a:p>
+            <a:pPr algn="ctr"/>
+          </a:p>
+        </p:txBody>
+      </p:sp>
+    </p:spTree>
+  </p:cSld>
+  <p:clrMapOvr>
+    <a:masterClrMapping/>
+  </p:clrMapOvr>
+</p:sld>
+</file>
+
+<file path=ppt/slides/slide9.xml><?xml version="1.0" encoding="utf-8"?>
 <p:sld xmlns:a="http://schemas.openxmlformats.org/drawingml/2006/main" xmlns:p="http://schemas.openxmlformats.org/presentationml/2006/main" xmlns:r="http://schemas.openxmlformats.org/officeDocument/2006/relationships">
   <p:cSld>
     <p:spTree>

</xml_diff>